<commit_message>
docs: update team name to Fino_50 (C-1)
</commit_message>
<xml_diff>
--- a/reports/presentation.pptx
+++ b/reports/presentation.pptx
@@ -2,24 +2,24 @@
 <file path=ppt/presentation.xml><?xml version="1.0" encoding="utf-8"?>
 <p:presentation xmlns:p="http://schemas.openxmlformats.org/presentationml/2006/main">
   <p:sldMasterIdLst>
-    <p:sldMasterId xmlns:r="http://schemas.openxmlformats.org/officeDocument/2006/relationships" id="2147483648" r:id="R5232b1cf96344b4f"/>
+    <p:sldMasterId xmlns:r="http://schemas.openxmlformats.org/officeDocument/2006/relationships" id="2147483648" r:id="R5e85e88611cc430c"/>
   </p:sldMasterIdLst>
   <p:notesMasterIdLst>
-    <p:notesMasterId xmlns:r="http://schemas.openxmlformats.org/officeDocument/2006/relationships" r:id="R6d515836bd974563"/>
+    <p:notesMasterId xmlns:r="http://schemas.openxmlformats.org/officeDocument/2006/relationships" r:id="Rb11e626dc2a1475a"/>
   </p:notesMasterIdLst>
   <p:sldIdLst>
-    <p:sldId xmlns:r="http://schemas.openxmlformats.org/officeDocument/2006/relationships" id="256" r:id="R7d0ffd8a61e94a71"/>
-    <p:sldId xmlns:r="http://schemas.openxmlformats.org/officeDocument/2006/relationships" id="257" r:id="R5ae781e7916a41a3"/>
-    <p:sldId xmlns:r="http://schemas.openxmlformats.org/officeDocument/2006/relationships" id="258" r:id="Rae6cfa801a7d4821"/>
-    <p:sldId xmlns:r="http://schemas.openxmlformats.org/officeDocument/2006/relationships" id="259" r:id="R24e05044c13341a0"/>
-    <p:sldId xmlns:r="http://schemas.openxmlformats.org/officeDocument/2006/relationships" id="260" r:id="Re22bb97ae3c6482d"/>
-    <p:sldId xmlns:r="http://schemas.openxmlformats.org/officeDocument/2006/relationships" id="261" r:id="R117b2d6b2b844d1b"/>
-    <p:sldId xmlns:r="http://schemas.openxmlformats.org/officeDocument/2006/relationships" id="262" r:id="Rd0b42dd2625e4825"/>
-    <p:sldId xmlns:r="http://schemas.openxmlformats.org/officeDocument/2006/relationships" id="263" r:id="R0ca5f56529d240dc"/>
-    <p:sldId xmlns:r="http://schemas.openxmlformats.org/officeDocument/2006/relationships" id="264" r:id="R1fbd8f0a873e47aa"/>
-    <p:sldId xmlns:r="http://schemas.openxmlformats.org/officeDocument/2006/relationships" id="265" r:id="R14429a7276bd4b98"/>
-    <p:sldId xmlns:r="http://schemas.openxmlformats.org/officeDocument/2006/relationships" id="266" r:id="R7abd3c4ad77b479e"/>
-    <p:sldId xmlns:r="http://schemas.openxmlformats.org/officeDocument/2006/relationships" id="267" r:id="R765d04b3d26b475e"/>
+    <p:sldId xmlns:r="http://schemas.openxmlformats.org/officeDocument/2006/relationships" id="256" r:id="R671f56b98f974209"/>
+    <p:sldId xmlns:r="http://schemas.openxmlformats.org/officeDocument/2006/relationships" id="257" r:id="Rda767b1f3d914014"/>
+    <p:sldId xmlns:r="http://schemas.openxmlformats.org/officeDocument/2006/relationships" id="258" r:id="R20c702b17c5f431f"/>
+    <p:sldId xmlns:r="http://schemas.openxmlformats.org/officeDocument/2006/relationships" id="259" r:id="R762864248cd0476a"/>
+    <p:sldId xmlns:r="http://schemas.openxmlformats.org/officeDocument/2006/relationships" id="260" r:id="R3a2ff5ac5dd941ce"/>
+    <p:sldId xmlns:r="http://schemas.openxmlformats.org/officeDocument/2006/relationships" id="261" r:id="R78a65b149e6843b2"/>
+    <p:sldId xmlns:r="http://schemas.openxmlformats.org/officeDocument/2006/relationships" id="262" r:id="Rb8e158c135d04f84"/>
+    <p:sldId xmlns:r="http://schemas.openxmlformats.org/officeDocument/2006/relationships" id="263" r:id="R67f4cb8ea5564ae9"/>
+    <p:sldId xmlns:r="http://schemas.openxmlformats.org/officeDocument/2006/relationships" id="264" r:id="R622c3f3eba544c51"/>
+    <p:sldId xmlns:r="http://schemas.openxmlformats.org/officeDocument/2006/relationships" id="265" r:id="R6c5ac98009c04412"/>
+    <p:sldId xmlns:r="http://schemas.openxmlformats.org/officeDocument/2006/relationships" id="266" r:id="Rb5cf5e1c356c4ff2"/>
+    <p:sldId xmlns:r="http://schemas.openxmlformats.org/officeDocument/2006/relationships" id="267" r:id="R583369ccfb364899"/>
   </p:sldIdLst>
   <p:sldSz cx="18288000" cy="10287000"/>
   <p:notesSz cx="6858000" cy="9144000"/>
@@ -1292,7 +1292,7 @@
   </p:cSld>
   <p:clrMap bg1="lt1" tx1="dk1" bg2="lt2" tx2="dk2" accent1="accent1" accent2="accent2" accent3="accent3" accent4="accent4" accent5="accent5" accent6="accent6" hlink="hlink" folHlink="folHlink"/>
   <p:sldLayoutIdLst>
-    <p:sldLayoutId xmlns:r="http://schemas.openxmlformats.org/officeDocument/2006/relationships" id="2147483649" r:id="R2bb12fa0164240b2"/>
+    <p:sldLayoutId xmlns:r="http://schemas.openxmlformats.org/officeDocument/2006/relationships" id="2147483649" r:id="R90184ce97bb74c08"/>
   </p:sldLayoutIdLst>
   <p:txStyles>
     <p:titleStyle>
@@ -1591,7 +1591,7 @@
           <p:cNvPr id="1" name="">
             <a:extLst xmlns:a="http://schemas.openxmlformats.org/drawingml/2006/main">
               <a:ext uri="{FF2B5EF4-FFF2-40B4-BE49-F238E27FC236}">
-                <a16:creationId xmlns:a16="http://schemas.microsoft.com/office/drawing/2014/main" id="{E4A3825B-6051-4619-96C2-F1F63B4CF0CF}"/>
+                <a16:creationId xmlns:a16="http://schemas.microsoft.com/office/drawing/2014/main" id="{744E5F51-AF7A-4B1B-A29C-B110974147A4}"/>
               </a:ext>
             </a:extLst>
           </p:cNvPr>
@@ -1626,7 +1626,7 @@
                   <a:srgbClr val="A7F3D0"/>
                 </a:solidFill>
               </a:rPr>
-              <a:t>NST DVA Capstone 2 Team</a:t>
+              <a:t>Fino_50 (C-1)</a:t>
             </a:r>
           </a:p>
         </p:txBody>
@@ -1636,7 +1636,7 @@
           <p:cNvPr id="2" name="">
             <a:extLst xmlns:a="http://schemas.openxmlformats.org/drawingml/2006/main">
               <a:ext uri="{FF2B5EF4-FFF2-40B4-BE49-F238E27FC236}">
-                <a16:creationId xmlns:a16="http://schemas.microsoft.com/office/drawing/2014/main" id="{39989142-812E-4144-AE73-F1AE73A1146C}"/>
+                <a16:creationId xmlns:a16="http://schemas.microsoft.com/office/drawing/2014/main" id="{07D752D6-6CCE-418F-ACF6-DEBCE08E7128}"/>
               </a:ext>
             </a:extLst>
           </p:cNvPr>
@@ -1681,7 +1681,7 @@
           <p:cNvPr id="3" name="">
             <a:extLst xmlns:a="http://schemas.openxmlformats.org/drawingml/2006/main">
               <a:ext uri="{FF2B5EF4-FFF2-40B4-BE49-F238E27FC236}">
-                <a16:creationId xmlns:a16="http://schemas.microsoft.com/office/drawing/2014/main" id="{1B5FEC6D-8400-445C-9848-218BA62A330D}"/>
+                <a16:creationId xmlns:a16="http://schemas.microsoft.com/office/drawing/2014/main" id="{3CF0355A-DDDE-41C4-9CFA-95CB4E002493}"/>
               </a:ext>
             </a:extLst>
           </p:cNvPr>
@@ -1714,7 +1714,7 @@
           <p:cNvPr id="4" name="">
             <a:extLst xmlns:a="http://schemas.openxmlformats.org/drawingml/2006/main">
               <a:ext uri="{FF2B5EF4-FFF2-40B4-BE49-F238E27FC236}">
-                <a16:creationId xmlns:a16="http://schemas.microsoft.com/office/drawing/2014/main" id="{9A67568E-133E-425F-97A5-F235EEA0225B}"/>
+                <a16:creationId xmlns:a16="http://schemas.microsoft.com/office/drawing/2014/main" id="{FBFCD33E-76B2-4FD0-B036-35119A39B4F7}"/>
               </a:ext>
             </a:extLst>
           </p:cNvPr>
@@ -1759,7 +1759,7 @@
           <p:cNvPr id="5" name="">
             <a:extLst xmlns:a="http://schemas.openxmlformats.org/drawingml/2006/main">
               <a:ext uri="{FF2B5EF4-FFF2-40B4-BE49-F238E27FC236}">
-                <a16:creationId xmlns:a16="http://schemas.microsoft.com/office/drawing/2014/main" id="{44C86465-7075-4170-85AC-48D1D399FD59}"/>
+                <a16:creationId xmlns:a16="http://schemas.microsoft.com/office/drawing/2014/main" id="{AEA63533-F2E9-44BF-9874-767FCF7DE53C}"/>
               </a:ext>
             </a:extLst>
           </p:cNvPr>
@@ -1804,7 +1804,7 @@
           <p:cNvPr id="6" name="">
             <a:extLst xmlns:a="http://schemas.openxmlformats.org/drawingml/2006/main">
               <a:ext uri="{FF2B5EF4-FFF2-40B4-BE49-F238E27FC236}">
-                <a16:creationId xmlns:a16="http://schemas.microsoft.com/office/drawing/2014/main" id="{AA86F64F-6F7F-4AD0-96DF-5490C0C74CE8}"/>
+                <a16:creationId xmlns:a16="http://schemas.microsoft.com/office/drawing/2014/main" id="{290B1D41-B620-4EF5-9F9A-158BCFF216D0}"/>
               </a:ext>
             </a:extLst>
           </p:cNvPr>
@@ -1849,7 +1849,7 @@
           <p:cNvPr id="7" name="cover-proof">
             <a:extLst xmlns:a="http://schemas.openxmlformats.org/drawingml/2006/main">
               <a:ext uri="{FF2B5EF4-FFF2-40B4-BE49-F238E27FC236}">
-                <a16:creationId xmlns:a16="http://schemas.microsoft.com/office/drawing/2014/main" id="{081D85D3-3D63-4974-A3D5-AD291B95F524}"/>
+                <a16:creationId xmlns:a16="http://schemas.microsoft.com/office/drawing/2014/main" id="{EF0119A1-61DA-45FE-9AC2-3BAEE26D9AFF}"/>
               </a:ext>
             </a:extLst>
           </p:cNvPr>
@@ -1876,7 +1876,7 @@
           <p:cNvPr id="8" name="">
             <a:extLst xmlns:a="http://schemas.openxmlformats.org/drawingml/2006/main">
               <a:ext uri="{FF2B5EF4-FFF2-40B4-BE49-F238E27FC236}">
-                <a16:creationId xmlns:a16="http://schemas.microsoft.com/office/drawing/2014/main" id="{75B8223D-D132-4A64-97FB-193EBD9329DC}"/>
+                <a16:creationId xmlns:a16="http://schemas.microsoft.com/office/drawing/2014/main" id="{0FEDD9FF-AFC8-45EA-8BA2-352F7BE03B79}"/>
               </a:ext>
             </a:extLst>
           </p:cNvPr>
@@ -1921,7 +1921,7 @@
           <p:cNvPr id="9" name="">
             <a:extLst xmlns:a="http://schemas.openxmlformats.org/drawingml/2006/main">
               <a:ext uri="{FF2B5EF4-FFF2-40B4-BE49-F238E27FC236}">
-                <a16:creationId xmlns:a16="http://schemas.microsoft.com/office/drawing/2014/main" id="{03B0E30C-520A-4A62-B2A6-F6BCCAAEF520}"/>
+                <a16:creationId xmlns:a16="http://schemas.microsoft.com/office/drawing/2014/main" id="{D4DF2414-C772-4621-BF88-C9417B958C9F}"/>
               </a:ext>
             </a:extLst>
           </p:cNvPr>
@@ -1966,7 +1966,7 @@
           <p:cNvPr id="10" name="">
             <a:extLst xmlns:a="http://schemas.openxmlformats.org/drawingml/2006/main">
               <a:ext uri="{FF2B5EF4-FFF2-40B4-BE49-F238E27FC236}">
-                <a16:creationId xmlns:a16="http://schemas.microsoft.com/office/drawing/2014/main" id="{0AA755E9-5FC1-47BD-A19F-A4D1A491201C}"/>
+                <a16:creationId xmlns:a16="http://schemas.microsoft.com/office/drawing/2014/main" id="{FD3AA6CD-4D04-421D-81E4-30A62D5A74B9}"/>
               </a:ext>
             </a:extLst>
           </p:cNvPr>
@@ -2011,7 +2011,7 @@
           <p:cNvPr id="11" name="">
             <a:extLst xmlns:a="http://schemas.openxmlformats.org/drawingml/2006/main">
               <a:ext uri="{FF2B5EF4-FFF2-40B4-BE49-F238E27FC236}">
-                <a16:creationId xmlns:a16="http://schemas.microsoft.com/office/drawing/2014/main" id="{F1E8D817-E6CE-454F-8839-73DE6DEA26C7}"/>
+                <a16:creationId xmlns:a16="http://schemas.microsoft.com/office/drawing/2014/main" id="{5DCD9CCA-C3B8-495E-B665-3DFF9171A2F7}"/>
               </a:ext>
             </a:extLst>
           </p:cNvPr>
@@ -2056,7 +2056,7 @@
           <p:cNvPr id="12" name="">
             <a:extLst xmlns:a="http://schemas.openxmlformats.org/drawingml/2006/main">
               <a:ext uri="{FF2B5EF4-FFF2-40B4-BE49-F238E27FC236}">
-                <a16:creationId xmlns:a16="http://schemas.microsoft.com/office/drawing/2014/main" id="{0990EE3F-3E49-4CA8-950C-31E37856D96A}"/>
+                <a16:creationId xmlns:a16="http://schemas.microsoft.com/office/drawing/2014/main" id="{45F4968A-299A-4952-8ABC-145066C11C58}"/>
               </a:ext>
             </a:extLst>
           </p:cNvPr>
@@ -2099,7 +2099,7 @@
     </p:spTree>
     <p:extLst>
       <p:ext uri="{BB962C8B-B14F-4D97-AF65-F5344CB8AC3E}">
-        <p14:creationId xmlns:p14="http://schemas.microsoft.com/office/powerpoint/2010/main" val="1442796750"/>
+        <p14:creationId xmlns:p14="http://schemas.microsoft.com/office/powerpoint/2010/main" val="1486601064"/>
       </p:ext>
     </p:extLst>
   </p:cSld>
@@ -2123,7 +2123,7 @@
           <p:cNvPr id="1" name="slide-title">
             <a:extLst xmlns:a="http://schemas.openxmlformats.org/drawingml/2006/main">
               <a:ext uri="{FF2B5EF4-FFF2-40B4-BE49-F238E27FC236}">
-                <a16:creationId xmlns:a16="http://schemas.microsoft.com/office/drawing/2014/main" id="{88A24E06-74D9-445A-870C-3A82415D6771}"/>
+                <a16:creationId xmlns:a16="http://schemas.microsoft.com/office/drawing/2014/main" id="{F660695F-A34A-4485-B420-10321FE2AD76}"/>
               </a:ext>
             </a:extLst>
           </p:cNvPr>
@@ -2168,7 +2168,7 @@
           <p:cNvPr id="2" name="">
             <a:extLst xmlns:a="http://schemas.openxmlformats.org/drawingml/2006/main">
               <a:ext uri="{FF2B5EF4-FFF2-40B4-BE49-F238E27FC236}">
-                <a16:creationId xmlns:a16="http://schemas.microsoft.com/office/drawing/2014/main" id="{7C57CDEB-89F4-4F2C-AFDE-E4106F09E0BF}"/>
+                <a16:creationId xmlns:a16="http://schemas.microsoft.com/office/drawing/2014/main" id="{9406DED8-1637-4586-8D34-984C330B23A7}"/>
               </a:ext>
             </a:extLst>
           </p:cNvPr>
@@ -2201,7 +2201,7 @@
           <p:cNvPr id="3" name="">
             <a:extLst xmlns:a="http://schemas.openxmlformats.org/drawingml/2006/main">
               <a:ext uri="{FF2B5EF4-FFF2-40B4-BE49-F238E27FC236}">
-                <a16:creationId xmlns:a16="http://schemas.microsoft.com/office/drawing/2014/main" id="{4F74C5D1-A26E-4188-BD2D-2B23E96D0D93}"/>
+                <a16:creationId xmlns:a16="http://schemas.microsoft.com/office/drawing/2014/main" id="{58D8842E-A36D-4F20-8B5D-4B113236D2BC}"/>
               </a:ext>
             </a:extLst>
           </p:cNvPr>
@@ -2228,7 +2228,7 @@
           <p:cNvPr id="4" name="">
             <a:extLst xmlns:a="http://schemas.openxmlformats.org/drawingml/2006/main">
               <a:ext uri="{FF2B5EF4-FFF2-40B4-BE49-F238E27FC236}">
-                <a16:creationId xmlns:a16="http://schemas.microsoft.com/office/drawing/2014/main" id="{BBC7914E-D4E1-404B-BE7E-A85A1985FA55}"/>
+                <a16:creationId xmlns:a16="http://schemas.microsoft.com/office/drawing/2014/main" id="{06336396-694E-4EAB-8C27-839DB6222050}"/>
               </a:ext>
             </a:extLst>
           </p:cNvPr>
@@ -2273,7 +2273,7 @@
           <p:cNvPr id="5" name="">
             <a:extLst xmlns:a="http://schemas.openxmlformats.org/drawingml/2006/main">
               <a:ext uri="{FF2B5EF4-FFF2-40B4-BE49-F238E27FC236}">
-                <a16:creationId xmlns:a16="http://schemas.microsoft.com/office/drawing/2014/main" id="{CAD217BA-28B2-4F3C-841C-73165C31568D}"/>
+                <a16:creationId xmlns:a16="http://schemas.microsoft.com/office/drawing/2014/main" id="{3407BAB3-95FC-4287-BCD2-B200087CA8A3}"/>
               </a:ext>
             </a:extLst>
           </p:cNvPr>
@@ -2300,7 +2300,7 @@
           <p:cNvPr id="6" name="">
             <a:extLst xmlns:a="http://schemas.openxmlformats.org/drawingml/2006/main">
               <a:ext uri="{FF2B5EF4-FFF2-40B4-BE49-F238E27FC236}">
-                <a16:creationId xmlns:a16="http://schemas.microsoft.com/office/drawing/2014/main" id="{02A69E26-16CC-4320-A2A6-A91A834F0BD1}"/>
+                <a16:creationId xmlns:a16="http://schemas.microsoft.com/office/drawing/2014/main" id="{798D59B8-7235-453C-9FB6-C42BBF8E712C}"/>
               </a:ext>
             </a:extLst>
           </p:cNvPr>
@@ -2345,7 +2345,7 @@
           <p:cNvPr id="7" name="">
             <a:extLst xmlns:a="http://schemas.openxmlformats.org/drawingml/2006/main">
               <a:ext uri="{FF2B5EF4-FFF2-40B4-BE49-F238E27FC236}">
-                <a16:creationId xmlns:a16="http://schemas.microsoft.com/office/drawing/2014/main" id="{31DD1FE1-8AA4-420D-9073-02A844D91167}"/>
+                <a16:creationId xmlns:a16="http://schemas.microsoft.com/office/drawing/2014/main" id="{69D9E5EF-45B9-4E8F-849F-FDF34BC75FD9}"/>
               </a:ext>
             </a:extLst>
           </p:cNvPr>
@@ -2372,7 +2372,7 @@
           <p:cNvPr id="8" name="">
             <a:extLst xmlns:a="http://schemas.openxmlformats.org/drawingml/2006/main">
               <a:ext uri="{FF2B5EF4-FFF2-40B4-BE49-F238E27FC236}">
-                <a16:creationId xmlns:a16="http://schemas.microsoft.com/office/drawing/2014/main" id="{1F0B79C0-A2CD-4889-B90D-B73AF6B33039}"/>
+                <a16:creationId xmlns:a16="http://schemas.microsoft.com/office/drawing/2014/main" id="{88DADF27-9FE4-4285-B9A2-50190CEACC1A}"/>
               </a:ext>
             </a:extLst>
           </p:cNvPr>
@@ -2417,7 +2417,7 @@
           <p:cNvPr id="9" name="">
             <a:extLst xmlns:a="http://schemas.openxmlformats.org/drawingml/2006/main">
               <a:ext uri="{FF2B5EF4-FFF2-40B4-BE49-F238E27FC236}">
-                <a16:creationId xmlns:a16="http://schemas.microsoft.com/office/drawing/2014/main" id="{190B2898-5D00-44D8-80A4-79876A075E41}"/>
+                <a16:creationId xmlns:a16="http://schemas.microsoft.com/office/drawing/2014/main" id="{4942A9B0-47AA-4D4C-A1E6-E661CF2942DA}"/>
               </a:ext>
             </a:extLst>
           </p:cNvPr>
@@ -2444,7 +2444,7 @@
           <p:cNvPr id="10" name="">
             <a:extLst xmlns:a="http://schemas.openxmlformats.org/drawingml/2006/main">
               <a:ext uri="{FF2B5EF4-FFF2-40B4-BE49-F238E27FC236}">
-                <a16:creationId xmlns:a16="http://schemas.microsoft.com/office/drawing/2014/main" id="{A46E41E1-9C7B-470E-91A3-A496DD8A9912}"/>
+                <a16:creationId xmlns:a16="http://schemas.microsoft.com/office/drawing/2014/main" id="{914396D6-C530-4463-B65A-3DC2A35E1AFE}"/>
               </a:ext>
             </a:extLst>
           </p:cNvPr>
@@ -2487,7 +2487,7 @@
     </p:spTree>
     <p:extLst>
       <p:ext uri="{BB962C8B-B14F-4D97-AF65-F5344CB8AC3E}">
-        <p14:creationId xmlns:p14="http://schemas.microsoft.com/office/powerpoint/2010/main" val="2068120095"/>
+        <p14:creationId xmlns:p14="http://schemas.microsoft.com/office/powerpoint/2010/main" val="638111662"/>
       </p:ext>
     </p:extLst>
   </p:cSld>
@@ -2511,7 +2511,7 @@
           <p:cNvPr id="1" name="slide-title">
             <a:extLst xmlns:a="http://schemas.openxmlformats.org/drawingml/2006/main">
               <a:ext uri="{FF2B5EF4-FFF2-40B4-BE49-F238E27FC236}">
-                <a16:creationId xmlns:a16="http://schemas.microsoft.com/office/drawing/2014/main" id="{FBFCED96-68C6-4F80-97C7-DB831AD09B24}"/>
+                <a16:creationId xmlns:a16="http://schemas.microsoft.com/office/drawing/2014/main" id="{52C86527-B97E-4623-AD2D-FE4AC908672E}"/>
               </a:ext>
             </a:extLst>
           </p:cNvPr>
@@ -2556,7 +2556,7 @@
           <p:cNvPr id="2" name="">
             <a:extLst xmlns:a="http://schemas.openxmlformats.org/drawingml/2006/main">
               <a:ext uri="{FF2B5EF4-FFF2-40B4-BE49-F238E27FC236}">
-                <a16:creationId xmlns:a16="http://schemas.microsoft.com/office/drawing/2014/main" id="{306C8D8B-B6DD-46B9-B0E7-E9C11D2CAD4F}"/>
+                <a16:creationId xmlns:a16="http://schemas.microsoft.com/office/drawing/2014/main" id="{975F2BA7-475C-4FF7-BF76-23C52F3A3D85}"/>
               </a:ext>
             </a:extLst>
           </p:cNvPr>
@@ -2589,7 +2589,7 @@
           <p:cNvPr id="3" name="">
             <a:extLst xmlns:a="http://schemas.openxmlformats.org/drawingml/2006/main">
               <a:ext uri="{FF2B5EF4-FFF2-40B4-BE49-F238E27FC236}">
-                <a16:creationId xmlns:a16="http://schemas.microsoft.com/office/drawing/2014/main" id="{0730093B-B4EF-4D86-AF7F-EA6CF5D912DC}"/>
+                <a16:creationId xmlns:a16="http://schemas.microsoft.com/office/drawing/2014/main" id="{9D6C95F7-E4E1-4253-BFB2-B6860E4BE886}"/>
               </a:ext>
             </a:extLst>
           </p:cNvPr>
@@ -2616,7 +2616,7 @@
           <p:cNvPr id="4" name="">
             <a:extLst xmlns:a="http://schemas.openxmlformats.org/drawingml/2006/main">
               <a:ext uri="{FF2B5EF4-FFF2-40B4-BE49-F238E27FC236}">
-                <a16:creationId xmlns:a16="http://schemas.microsoft.com/office/drawing/2014/main" id="{A2DC07C5-8D49-4757-B656-A813638AB1F3}"/>
+                <a16:creationId xmlns:a16="http://schemas.microsoft.com/office/drawing/2014/main" id="{3028A421-1CB5-44B8-98C3-65B86E23690E}"/>
               </a:ext>
             </a:extLst>
           </p:cNvPr>
@@ -2661,7 +2661,7 @@
           <p:cNvPr id="5" name="">
             <a:extLst xmlns:a="http://schemas.openxmlformats.org/drawingml/2006/main">
               <a:ext uri="{FF2B5EF4-FFF2-40B4-BE49-F238E27FC236}">
-                <a16:creationId xmlns:a16="http://schemas.microsoft.com/office/drawing/2014/main" id="{FA75807A-26F7-4A32-A04C-0DC8DF32DD9F}"/>
+                <a16:creationId xmlns:a16="http://schemas.microsoft.com/office/drawing/2014/main" id="{944F0382-0A02-4D15-B86C-52B555BFCFEE}"/>
               </a:ext>
             </a:extLst>
           </p:cNvPr>
@@ -2688,7 +2688,7 @@
           <p:cNvPr id="6" name="">
             <a:extLst xmlns:a="http://schemas.openxmlformats.org/drawingml/2006/main">
               <a:ext uri="{FF2B5EF4-FFF2-40B4-BE49-F238E27FC236}">
-                <a16:creationId xmlns:a16="http://schemas.microsoft.com/office/drawing/2014/main" id="{839758DF-EEA5-49D2-82C5-64323017D5AC}"/>
+                <a16:creationId xmlns:a16="http://schemas.microsoft.com/office/drawing/2014/main" id="{5096B1F0-79A4-48E9-A2D4-4CD2AC293060}"/>
               </a:ext>
             </a:extLst>
           </p:cNvPr>
@@ -2733,7 +2733,7 @@
           <p:cNvPr id="7" name="">
             <a:extLst xmlns:a="http://schemas.openxmlformats.org/drawingml/2006/main">
               <a:ext uri="{FF2B5EF4-FFF2-40B4-BE49-F238E27FC236}">
-                <a16:creationId xmlns:a16="http://schemas.microsoft.com/office/drawing/2014/main" id="{DD4F9C3B-9947-4B70-92E6-34E789D4DF3E}"/>
+                <a16:creationId xmlns:a16="http://schemas.microsoft.com/office/drawing/2014/main" id="{1B4CFF98-5555-4C96-AD76-9D96CCCACAF8}"/>
               </a:ext>
             </a:extLst>
           </p:cNvPr>
@@ -2760,7 +2760,7 @@
           <p:cNvPr id="8" name="">
             <a:extLst xmlns:a="http://schemas.openxmlformats.org/drawingml/2006/main">
               <a:ext uri="{FF2B5EF4-FFF2-40B4-BE49-F238E27FC236}">
-                <a16:creationId xmlns:a16="http://schemas.microsoft.com/office/drawing/2014/main" id="{DC7D4AC9-97E7-454B-B071-C65AFFCC13CD}"/>
+                <a16:creationId xmlns:a16="http://schemas.microsoft.com/office/drawing/2014/main" id="{9ADDAA2B-622E-4286-9BEE-A7C0FF1D8FF2}"/>
               </a:ext>
             </a:extLst>
           </p:cNvPr>
@@ -2805,7 +2805,7 @@
           <p:cNvPr id="9" name="">
             <a:extLst xmlns:a="http://schemas.openxmlformats.org/drawingml/2006/main">
               <a:ext uri="{FF2B5EF4-FFF2-40B4-BE49-F238E27FC236}">
-                <a16:creationId xmlns:a16="http://schemas.microsoft.com/office/drawing/2014/main" id="{33105717-CCA8-458A-9921-64F7C623A45B}"/>
+                <a16:creationId xmlns:a16="http://schemas.microsoft.com/office/drawing/2014/main" id="{F52EA48F-5449-4000-B1DC-6ACE2858F5BD}"/>
               </a:ext>
             </a:extLst>
           </p:cNvPr>
@@ -2832,7 +2832,7 @@
           <p:cNvPr id="10" name="">
             <a:extLst xmlns:a="http://schemas.openxmlformats.org/drawingml/2006/main">
               <a:ext uri="{FF2B5EF4-FFF2-40B4-BE49-F238E27FC236}">
-                <a16:creationId xmlns:a16="http://schemas.microsoft.com/office/drawing/2014/main" id="{FBD897D4-F416-4AA1-83FA-097AE6B5BA2D}"/>
+                <a16:creationId xmlns:a16="http://schemas.microsoft.com/office/drawing/2014/main" id="{73995924-D2D1-460A-B30F-14BBE3E0D473}"/>
               </a:ext>
             </a:extLst>
           </p:cNvPr>
@@ -2877,7 +2877,7 @@
           <p:cNvPr id="11" name="">
             <a:extLst xmlns:a="http://schemas.openxmlformats.org/drawingml/2006/main">
               <a:ext uri="{FF2B5EF4-FFF2-40B4-BE49-F238E27FC236}">
-                <a16:creationId xmlns:a16="http://schemas.microsoft.com/office/drawing/2014/main" id="{C3868815-9849-416F-86FA-8E9C7573673F}"/>
+                <a16:creationId xmlns:a16="http://schemas.microsoft.com/office/drawing/2014/main" id="{DF4E6555-9100-4F60-9ACA-154A65F4C7F5}"/>
               </a:ext>
             </a:extLst>
           </p:cNvPr>
@@ -2904,7 +2904,7 @@
           <p:cNvPr id="12" name="">
             <a:extLst xmlns:a="http://schemas.openxmlformats.org/drawingml/2006/main">
               <a:ext uri="{FF2B5EF4-FFF2-40B4-BE49-F238E27FC236}">
-                <a16:creationId xmlns:a16="http://schemas.microsoft.com/office/drawing/2014/main" id="{A95B5105-021B-432E-8831-DC09388FC2A1}"/>
+                <a16:creationId xmlns:a16="http://schemas.microsoft.com/office/drawing/2014/main" id="{ACFF69C9-462A-49B7-B239-D0CA620299B8}"/>
               </a:ext>
             </a:extLst>
           </p:cNvPr>
@@ -2947,7 +2947,7 @@
     </p:spTree>
     <p:extLst>
       <p:ext uri="{BB962C8B-B14F-4D97-AF65-F5344CB8AC3E}">
-        <p14:creationId xmlns:p14="http://schemas.microsoft.com/office/powerpoint/2010/main" val="252788071"/>
+        <p14:creationId xmlns:p14="http://schemas.microsoft.com/office/powerpoint/2010/main" val="294959369"/>
       </p:ext>
     </p:extLst>
   </p:cSld>
@@ -2971,7 +2971,7 @@
           <p:cNvPr id="1" name="slide-title">
             <a:extLst xmlns:a="http://schemas.openxmlformats.org/drawingml/2006/main">
               <a:ext uri="{FF2B5EF4-FFF2-40B4-BE49-F238E27FC236}">
-                <a16:creationId xmlns:a16="http://schemas.microsoft.com/office/drawing/2014/main" id="{3FCEF1D6-9F69-4120-97EB-4D90A6EB81FA}"/>
+                <a16:creationId xmlns:a16="http://schemas.microsoft.com/office/drawing/2014/main" id="{C17364B3-B425-429B-973F-42FD67E46D65}"/>
               </a:ext>
             </a:extLst>
           </p:cNvPr>
@@ -3016,7 +3016,7 @@
           <p:cNvPr id="2" name="">
             <a:extLst xmlns:a="http://schemas.openxmlformats.org/drawingml/2006/main">
               <a:ext uri="{FF2B5EF4-FFF2-40B4-BE49-F238E27FC236}">
-                <a16:creationId xmlns:a16="http://schemas.microsoft.com/office/drawing/2014/main" id="{178731AE-0922-418A-946D-F2799D4E7413}"/>
+                <a16:creationId xmlns:a16="http://schemas.microsoft.com/office/drawing/2014/main" id="{8D4C877C-3868-4E76-B1C6-CA630D8C902A}"/>
               </a:ext>
             </a:extLst>
           </p:cNvPr>
@@ -3049,7 +3049,7 @@
           <p:cNvPr id="3" name="">
             <a:extLst xmlns:a="http://schemas.openxmlformats.org/drawingml/2006/main">
               <a:ext uri="{FF2B5EF4-FFF2-40B4-BE49-F238E27FC236}">
-                <a16:creationId xmlns:a16="http://schemas.microsoft.com/office/drawing/2014/main" id="{2D36C3B5-3580-4E66-8DE9-A74E5EE34CA7}"/>
+                <a16:creationId xmlns:a16="http://schemas.microsoft.com/office/drawing/2014/main" id="{6E03E32F-46EA-4FEC-913A-ACA944C1C8CC}"/>
               </a:ext>
             </a:extLst>
           </p:cNvPr>
@@ -3076,7 +3076,7 @@
           <p:cNvPr id="4" name="">
             <a:extLst xmlns:a="http://schemas.openxmlformats.org/drawingml/2006/main">
               <a:ext uri="{FF2B5EF4-FFF2-40B4-BE49-F238E27FC236}">
-                <a16:creationId xmlns:a16="http://schemas.microsoft.com/office/drawing/2014/main" id="{EB7E4240-0FF3-438B-AF0B-703FA6D79D3F}"/>
+                <a16:creationId xmlns:a16="http://schemas.microsoft.com/office/drawing/2014/main" id="{F2046398-E853-4F6D-921F-E359A0120EA6}"/>
               </a:ext>
             </a:extLst>
           </p:cNvPr>
@@ -3121,7 +3121,7 @@
           <p:cNvPr id="5" name="">
             <a:extLst xmlns:a="http://schemas.openxmlformats.org/drawingml/2006/main">
               <a:ext uri="{FF2B5EF4-FFF2-40B4-BE49-F238E27FC236}">
-                <a16:creationId xmlns:a16="http://schemas.microsoft.com/office/drawing/2014/main" id="{743C8F1C-B158-4FC8-BCF7-1DBB5B5F7E5A}"/>
+                <a16:creationId xmlns:a16="http://schemas.microsoft.com/office/drawing/2014/main" id="{8935262C-0624-4054-B3E1-34C6BD77A800}"/>
               </a:ext>
             </a:extLst>
           </p:cNvPr>
@@ -3148,7 +3148,7 @@
           <p:cNvPr id="6" name="">
             <a:extLst xmlns:a="http://schemas.openxmlformats.org/drawingml/2006/main">
               <a:ext uri="{FF2B5EF4-FFF2-40B4-BE49-F238E27FC236}">
-                <a16:creationId xmlns:a16="http://schemas.microsoft.com/office/drawing/2014/main" id="{489DA790-5477-4849-8A1C-7468E985EB08}"/>
+                <a16:creationId xmlns:a16="http://schemas.microsoft.com/office/drawing/2014/main" id="{7BBFB4B8-4E16-4749-A19D-FDFC7AE7D723}"/>
               </a:ext>
             </a:extLst>
           </p:cNvPr>
@@ -3193,7 +3193,7 @@
           <p:cNvPr id="7" name="">
             <a:extLst xmlns:a="http://schemas.openxmlformats.org/drawingml/2006/main">
               <a:ext uri="{FF2B5EF4-FFF2-40B4-BE49-F238E27FC236}">
-                <a16:creationId xmlns:a16="http://schemas.microsoft.com/office/drawing/2014/main" id="{83FCC968-68CF-4E86-879A-6F1A8D877262}"/>
+                <a16:creationId xmlns:a16="http://schemas.microsoft.com/office/drawing/2014/main" id="{DE9A472C-CC77-4DB9-B8E3-026ADBE1B9EF}"/>
               </a:ext>
             </a:extLst>
           </p:cNvPr>
@@ -3220,7 +3220,7 @@
           <p:cNvPr id="8" name="">
             <a:extLst xmlns:a="http://schemas.openxmlformats.org/drawingml/2006/main">
               <a:ext uri="{FF2B5EF4-FFF2-40B4-BE49-F238E27FC236}">
-                <a16:creationId xmlns:a16="http://schemas.microsoft.com/office/drawing/2014/main" id="{43A6D93A-1F0D-472D-802C-BCB24452E27F}"/>
+                <a16:creationId xmlns:a16="http://schemas.microsoft.com/office/drawing/2014/main" id="{F3215251-E808-4A3C-8F8C-E0E7A077E88F}"/>
               </a:ext>
             </a:extLst>
           </p:cNvPr>
@@ -3263,7 +3263,7 @@
     </p:spTree>
     <p:extLst>
       <p:ext uri="{BB962C8B-B14F-4D97-AF65-F5344CB8AC3E}">
-        <p14:creationId xmlns:p14="http://schemas.microsoft.com/office/powerpoint/2010/main" val="449751004"/>
+        <p14:creationId xmlns:p14="http://schemas.microsoft.com/office/powerpoint/2010/main" val="1670077863"/>
       </p:ext>
     </p:extLst>
   </p:cSld>
@@ -3287,7 +3287,7 @@
           <p:cNvPr id="1" name="slide-title">
             <a:extLst xmlns:a="http://schemas.openxmlformats.org/drawingml/2006/main">
               <a:ext uri="{FF2B5EF4-FFF2-40B4-BE49-F238E27FC236}">
-                <a16:creationId xmlns:a16="http://schemas.microsoft.com/office/drawing/2014/main" id="{81C1AC09-E26E-4B59-87FD-EA6A645EDFA6}"/>
+                <a16:creationId xmlns:a16="http://schemas.microsoft.com/office/drawing/2014/main" id="{2B826BEA-D38B-40E4-9A15-53050504EB3A}"/>
               </a:ext>
             </a:extLst>
           </p:cNvPr>
@@ -3332,7 +3332,7 @@
           <p:cNvPr id="2" name="">
             <a:extLst xmlns:a="http://schemas.openxmlformats.org/drawingml/2006/main">
               <a:ext uri="{FF2B5EF4-FFF2-40B4-BE49-F238E27FC236}">
-                <a16:creationId xmlns:a16="http://schemas.microsoft.com/office/drawing/2014/main" id="{5491D22F-B411-419B-B834-F58A94A23EFE}"/>
+                <a16:creationId xmlns:a16="http://schemas.microsoft.com/office/drawing/2014/main" id="{8E6E919F-F0AE-4ADB-ADA3-3B707EE26D79}"/>
               </a:ext>
             </a:extLst>
           </p:cNvPr>
@@ -3365,7 +3365,7 @@
           <p:cNvPr id="3" name="">
             <a:extLst xmlns:a="http://schemas.openxmlformats.org/drawingml/2006/main">
               <a:ext uri="{FF2B5EF4-FFF2-40B4-BE49-F238E27FC236}">
-                <a16:creationId xmlns:a16="http://schemas.microsoft.com/office/drawing/2014/main" id="{77C5E2CD-769C-477B-96A4-F56ECD2853AA}"/>
+                <a16:creationId xmlns:a16="http://schemas.microsoft.com/office/drawing/2014/main" id="{1AD607FF-66AF-48DB-A0D7-9E209A5E88EC}"/>
               </a:ext>
             </a:extLst>
           </p:cNvPr>
@@ -3392,7 +3392,7 @@
           <p:cNvPr id="4" name="">
             <a:extLst xmlns:a="http://schemas.openxmlformats.org/drawingml/2006/main">
               <a:ext uri="{FF2B5EF4-FFF2-40B4-BE49-F238E27FC236}">
-                <a16:creationId xmlns:a16="http://schemas.microsoft.com/office/drawing/2014/main" id="{74150242-6564-4F3E-AACE-081E52B50AB0}"/>
+                <a16:creationId xmlns:a16="http://schemas.microsoft.com/office/drawing/2014/main" id="{7204D698-C4F2-42C2-8AEF-EE0D74A6693E}"/>
               </a:ext>
             </a:extLst>
           </p:cNvPr>
@@ -3437,7 +3437,7 @@
           <p:cNvPr id="5" name="">
             <a:extLst xmlns:a="http://schemas.openxmlformats.org/drawingml/2006/main">
               <a:ext uri="{FF2B5EF4-FFF2-40B4-BE49-F238E27FC236}">
-                <a16:creationId xmlns:a16="http://schemas.microsoft.com/office/drawing/2014/main" id="{F08C3ACB-C97A-4E46-90E0-80F8863EF2C7}"/>
+                <a16:creationId xmlns:a16="http://schemas.microsoft.com/office/drawing/2014/main" id="{B10ECB49-91B7-43D4-9BB7-52A1C6192046}"/>
               </a:ext>
             </a:extLst>
           </p:cNvPr>
@@ -3464,7 +3464,7 @@
           <p:cNvPr id="6" name="">
             <a:extLst xmlns:a="http://schemas.openxmlformats.org/drawingml/2006/main">
               <a:ext uri="{FF2B5EF4-FFF2-40B4-BE49-F238E27FC236}">
-                <a16:creationId xmlns:a16="http://schemas.microsoft.com/office/drawing/2014/main" id="{C14F0B30-1999-4FD3-960D-76B5FF6E8FFE}"/>
+                <a16:creationId xmlns:a16="http://schemas.microsoft.com/office/drawing/2014/main" id="{289B236F-B058-4473-A757-D471B79059A6}"/>
               </a:ext>
             </a:extLst>
           </p:cNvPr>
@@ -3509,7 +3509,7 @@
           <p:cNvPr id="7" name="">
             <a:extLst xmlns:a="http://schemas.openxmlformats.org/drawingml/2006/main">
               <a:ext uri="{FF2B5EF4-FFF2-40B4-BE49-F238E27FC236}">
-                <a16:creationId xmlns:a16="http://schemas.microsoft.com/office/drawing/2014/main" id="{E65C2800-7D69-4F1A-97A6-CB092A277B4E}"/>
+                <a16:creationId xmlns:a16="http://schemas.microsoft.com/office/drawing/2014/main" id="{C496EF89-E8C9-44AC-8749-746413D95E22}"/>
               </a:ext>
             </a:extLst>
           </p:cNvPr>
@@ -3536,7 +3536,7 @@
           <p:cNvPr id="8" name="">
             <a:extLst xmlns:a="http://schemas.openxmlformats.org/drawingml/2006/main">
               <a:ext uri="{FF2B5EF4-FFF2-40B4-BE49-F238E27FC236}">
-                <a16:creationId xmlns:a16="http://schemas.microsoft.com/office/drawing/2014/main" id="{29DA2CB7-F75F-4695-ABF9-1C48AD11BDEF}"/>
+                <a16:creationId xmlns:a16="http://schemas.microsoft.com/office/drawing/2014/main" id="{0D9A8B4E-1B9A-49B1-99ED-58804A8F958D}"/>
               </a:ext>
             </a:extLst>
           </p:cNvPr>
@@ -3579,7 +3579,7 @@
     </p:spTree>
     <p:extLst>
       <p:ext uri="{BB962C8B-B14F-4D97-AF65-F5344CB8AC3E}">
-        <p14:creationId xmlns:p14="http://schemas.microsoft.com/office/powerpoint/2010/main" val="1349010625"/>
+        <p14:creationId xmlns:p14="http://schemas.microsoft.com/office/powerpoint/2010/main" val="1266852898"/>
       </p:ext>
     </p:extLst>
   </p:cSld>
@@ -3603,7 +3603,7 @@
           <p:cNvPr id="1" name="slide-title">
             <a:extLst xmlns:a="http://schemas.openxmlformats.org/drawingml/2006/main">
               <a:ext uri="{FF2B5EF4-FFF2-40B4-BE49-F238E27FC236}">
-                <a16:creationId xmlns:a16="http://schemas.microsoft.com/office/drawing/2014/main" id="{82BBD7E3-002E-4573-A70D-7F2A2FBDEF13}"/>
+                <a16:creationId xmlns:a16="http://schemas.microsoft.com/office/drawing/2014/main" id="{ACB9803B-2ECB-4C35-A562-DEE8EF612959}"/>
               </a:ext>
             </a:extLst>
           </p:cNvPr>
@@ -3648,7 +3648,7 @@
           <p:cNvPr id="2" name="">
             <a:extLst xmlns:a="http://schemas.openxmlformats.org/drawingml/2006/main">
               <a:ext uri="{FF2B5EF4-FFF2-40B4-BE49-F238E27FC236}">
-                <a16:creationId xmlns:a16="http://schemas.microsoft.com/office/drawing/2014/main" id="{96673DCD-20BE-46CF-8E00-2D4A351FCD67}"/>
+                <a16:creationId xmlns:a16="http://schemas.microsoft.com/office/drawing/2014/main" id="{7CC41DBC-2A39-4C8A-A32D-EC87E4528082}"/>
               </a:ext>
             </a:extLst>
           </p:cNvPr>
@@ -3681,7 +3681,7 @@
           <p:cNvPr id="3" name="">
             <a:extLst xmlns:a="http://schemas.openxmlformats.org/drawingml/2006/main">
               <a:ext uri="{FF2B5EF4-FFF2-40B4-BE49-F238E27FC236}">
-                <a16:creationId xmlns:a16="http://schemas.microsoft.com/office/drawing/2014/main" id="{53F197CF-9E25-43DE-A56C-58CB102AC61C}"/>
+                <a16:creationId xmlns:a16="http://schemas.microsoft.com/office/drawing/2014/main" id="{65C6C432-5123-4D07-8C4C-008F8160420D}"/>
               </a:ext>
             </a:extLst>
           </p:cNvPr>
@@ -3708,7 +3708,7 @@
           <p:cNvPr id="4" name="">
             <a:extLst xmlns:a="http://schemas.openxmlformats.org/drawingml/2006/main">
               <a:ext uri="{FF2B5EF4-FFF2-40B4-BE49-F238E27FC236}">
-                <a16:creationId xmlns:a16="http://schemas.microsoft.com/office/drawing/2014/main" id="{62A9F93A-61B4-4214-89EB-8473E522919D}"/>
+                <a16:creationId xmlns:a16="http://schemas.microsoft.com/office/drawing/2014/main" id="{E2A18769-7E08-4681-851A-727ED550B747}"/>
               </a:ext>
             </a:extLst>
           </p:cNvPr>
@@ -3753,7 +3753,7 @@
           <p:cNvPr id="5" name="">
             <a:extLst xmlns:a="http://schemas.openxmlformats.org/drawingml/2006/main">
               <a:ext uri="{FF2B5EF4-FFF2-40B4-BE49-F238E27FC236}">
-                <a16:creationId xmlns:a16="http://schemas.microsoft.com/office/drawing/2014/main" id="{62FF4F31-2F6A-4DBB-B20D-7CF9A40671AB}"/>
+                <a16:creationId xmlns:a16="http://schemas.microsoft.com/office/drawing/2014/main" id="{1ED2E67E-3F7F-4630-9A2F-2DA5D50BAA9B}"/>
               </a:ext>
             </a:extLst>
           </p:cNvPr>
@@ -3780,7 +3780,7 @@
           <p:cNvPr id="6" name="">
             <a:extLst xmlns:a="http://schemas.openxmlformats.org/drawingml/2006/main">
               <a:ext uri="{FF2B5EF4-FFF2-40B4-BE49-F238E27FC236}">
-                <a16:creationId xmlns:a16="http://schemas.microsoft.com/office/drawing/2014/main" id="{1FFAB20A-D043-4C92-9F05-4159FA519BAC}"/>
+                <a16:creationId xmlns:a16="http://schemas.microsoft.com/office/drawing/2014/main" id="{A4A27D1E-1A85-4382-85A0-651FBB24EA6E}"/>
               </a:ext>
             </a:extLst>
           </p:cNvPr>
@@ -3825,7 +3825,7 @@
           <p:cNvPr id="7" name="">
             <a:extLst xmlns:a="http://schemas.openxmlformats.org/drawingml/2006/main">
               <a:ext uri="{FF2B5EF4-FFF2-40B4-BE49-F238E27FC236}">
-                <a16:creationId xmlns:a16="http://schemas.microsoft.com/office/drawing/2014/main" id="{5502A87F-687B-46BD-8805-26FB9B8C09EC}"/>
+                <a16:creationId xmlns:a16="http://schemas.microsoft.com/office/drawing/2014/main" id="{07D0B40B-0F6B-4ED6-970A-DC9392CC2409}"/>
               </a:ext>
             </a:extLst>
           </p:cNvPr>
@@ -3852,7 +3852,7 @@
           <p:cNvPr id="8" name="">
             <a:extLst xmlns:a="http://schemas.openxmlformats.org/drawingml/2006/main">
               <a:ext uri="{FF2B5EF4-FFF2-40B4-BE49-F238E27FC236}">
-                <a16:creationId xmlns:a16="http://schemas.microsoft.com/office/drawing/2014/main" id="{B3C13F36-4D03-4985-A250-9917500DEAAD}"/>
+                <a16:creationId xmlns:a16="http://schemas.microsoft.com/office/drawing/2014/main" id="{41D49ECF-DE2B-4A03-B2CA-52C2112DF502}"/>
               </a:ext>
             </a:extLst>
           </p:cNvPr>
@@ -3897,7 +3897,7 @@
           <p:cNvPr id="9" name="">
             <a:extLst xmlns:a="http://schemas.openxmlformats.org/drawingml/2006/main">
               <a:ext uri="{FF2B5EF4-FFF2-40B4-BE49-F238E27FC236}">
-                <a16:creationId xmlns:a16="http://schemas.microsoft.com/office/drawing/2014/main" id="{AD5EF84E-31F2-424F-8C56-295E0534F0EA}"/>
+                <a16:creationId xmlns:a16="http://schemas.microsoft.com/office/drawing/2014/main" id="{5408BA06-F3BB-4CEB-968B-CD6DFEBEF51A}"/>
               </a:ext>
             </a:extLst>
           </p:cNvPr>
@@ -3924,7 +3924,7 @@
           <p:cNvPr id="10" name="">
             <a:extLst xmlns:a="http://schemas.openxmlformats.org/drawingml/2006/main">
               <a:ext uri="{FF2B5EF4-FFF2-40B4-BE49-F238E27FC236}">
-                <a16:creationId xmlns:a16="http://schemas.microsoft.com/office/drawing/2014/main" id="{6DD9B681-B768-441A-8910-2BD5E6E31CCC}"/>
+                <a16:creationId xmlns:a16="http://schemas.microsoft.com/office/drawing/2014/main" id="{719CC928-E139-4192-99DC-A76F23FB3482}"/>
               </a:ext>
             </a:extLst>
           </p:cNvPr>
@@ -3967,7 +3967,7 @@
     </p:spTree>
     <p:extLst>
       <p:ext uri="{BB962C8B-B14F-4D97-AF65-F5344CB8AC3E}">
-        <p14:creationId xmlns:p14="http://schemas.microsoft.com/office/powerpoint/2010/main" val="742625619"/>
+        <p14:creationId xmlns:p14="http://schemas.microsoft.com/office/powerpoint/2010/main" val="608836206"/>
       </p:ext>
     </p:extLst>
   </p:cSld>
@@ -3991,7 +3991,7 @@
           <p:cNvPr id="1" name="slide-title">
             <a:extLst xmlns:a="http://schemas.openxmlformats.org/drawingml/2006/main">
               <a:ext uri="{FF2B5EF4-FFF2-40B4-BE49-F238E27FC236}">
-                <a16:creationId xmlns:a16="http://schemas.microsoft.com/office/drawing/2014/main" id="{43DD3FB9-E7E2-4065-AC49-3AB8DC81CE40}"/>
+                <a16:creationId xmlns:a16="http://schemas.microsoft.com/office/drawing/2014/main" id="{33A03A65-7FA0-4BEC-A42F-19A010C84258}"/>
               </a:ext>
             </a:extLst>
           </p:cNvPr>
@@ -4036,7 +4036,7 @@
           <p:cNvPr id="2" name="">
             <a:extLst xmlns:a="http://schemas.openxmlformats.org/drawingml/2006/main">
               <a:ext uri="{FF2B5EF4-FFF2-40B4-BE49-F238E27FC236}">
-                <a16:creationId xmlns:a16="http://schemas.microsoft.com/office/drawing/2014/main" id="{1E7F3C9C-B6EB-4589-A054-1C766B9D89A2}"/>
+                <a16:creationId xmlns:a16="http://schemas.microsoft.com/office/drawing/2014/main" id="{9F8C1FC8-266B-48B8-B695-32713E909987}"/>
               </a:ext>
             </a:extLst>
           </p:cNvPr>
@@ -4069,7 +4069,7 @@
           <p:cNvPr id="3" name="">
             <a:extLst xmlns:a="http://schemas.openxmlformats.org/drawingml/2006/main">
               <a:ext uri="{FF2B5EF4-FFF2-40B4-BE49-F238E27FC236}">
-                <a16:creationId xmlns:a16="http://schemas.microsoft.com/office/drawing/2014/main" id="{FF0CA51A-7CC2-4551-A75C-30A3A86112AA}"/>
+                <a16:creationId xmlns:a16="http://schemas.microsoft.com/office/drawing/2014/main" id="{4947B9FC-ED43-4311-9367-7D8ACE419E7D}"/>
               </a:ext>
             </a:extLst>
           </p:cNvPr>
@@ -4096,7 +4096,7 @@
           <p:cNvPr id="4" name="">
             <a:extLst xmlns:a="http://schemas.openxmlformats.org/drawingml/2006/main">
               <a:ext uri="{FF2B5EF4-FFF2-40B4-BE49-F238E27FC236}">
-                <a16:creationId xmlns:a16="http://schemas.microsoft.com/office/drawing/2014/main" id="{73BC2A71-9ADE-43FB-BEEA-E5BF2DEE06A1}"/>
+                <a16:creationId xmlns:a16="http://schemas.microsoft.com/office/drawing/2014/main" id="{1EE0F2BB-F3C5-4D44-AAE4-E2E55B89C0A3}"/>
               </a:ext>
             </a:extLst>
           </p:cNvPr>
@@ -4141,7 +4141,7 @@
           <p:cNvPr id="5" name="">
             <a:extLst xmlns:a="http://schemas.openxmlformats.org/drawingml/2006/main">
               <a:ext uri="{FF2B5EF4-FFF2-40B4-BE49-F238E27FC236}">
-                <a16:creationId xmlns:a16="http://schemas.microsoft.com/office/drawing/2014/main" id="{4718D0F0-DC0F-4E89-8EA2-BC3F2D5824F9}"/>
+                <a16:creationId xmlns:a16="http://schemas.microsoft.com/office/drawing/2014/main" id="{9AC10D7D-F58D-4E45-9260-ED8CB959EB61}"/>
               </a:ext>
             </a:extLst>
           </p:cNvPr>
@@ -4168,7 +4168,7 @@
           <p:cNvPr id="6" name="">
             <a:extLst xmlns:a="http://schemas.openxmlformats.org/drawingml/2006/main">
               <a:ext uri="{FF2B5EF4-FFF2-40B4-BE49-F238E27FC236}">
-                <a16:creationId xmlns:a16="http://schemas.microsoft.com/office/drawing/2014/main" id="{6375EF54-8140-480B-9401-DDC6406C61BB}"/>
+                <a16:creationId xmlns:a16="http://schemas.microsoft.com/office/drawing/2014/main" id="{486E233A-3150-4B7F-8B24-DD317AAD3969}"/>
               </a:ext>
             </a:extLst>
           </p:cNvPr>
@@ -4213,7 +4213,7 @@
           <p:cNvPr id="7" name="">
             <a:extLst xmlns:a="http://schemas.openxmlformats.org/drawingml/2006/main">
               <a:ext uri="{FF2B5EF4-FFF2-40B4-BE49-F238E27FC236}">
-                <a16:creationId xmlns:a16="http://schemas.microsoft.com/office/drawing/2014/main" id="{3DF15B70-E379-4BE0-B9DC-8372AF187007}"/>
+                <a16:creationId xmlns:a16="http://schemas.microsoft.com/office/drawing/2014/main" id="{CCAC8E1A-BA83-4F92-81FF-DA6AEEB458D8}"/>
               </a:ext>
             </a:extLst>
           </p:cNvPr>
@@ -4240,7 +4240,7 @@
           <p:cNvPr id="8" name="">
             <a:extLst xmlns:a="http://schemas.openxmlformats.org/drawingml/2006/main">
               <a:ext uri="{FF2B5EF4-FFF2-40B4-BE49-F238E27FC236}">
-                <a16:creationId xmlns:a16="http://schemas.microsoft.com/office/drawing/2014/main" id="{E18D0A4D-E0E7-4BA4-BB19-E0859E21DB77}"/>
+                <a16:creationId xmlns:a16="http://schemas.microsoft.com/office/drawing/2014/main" id="{375F5A27-3F68-4495-807B-6B49FAEC4AEC}"/>
               </a:ext>
             </a:extLst>
           </p:cNvPr>
@@ -4283,7 +4283,7 @@
     </p:spTree>
     <p:extLst>
       <p:ext uri="{BB962C8B-B14F-4D97-AF65-F5344CB8AC3E}">
-        <p14:creationId xmlns:p14="http://schemas.microsoft.com/office/powerpoint/2010/main" val="1887544088"/>
+        <p14:creationId xmlns:p14="http://schemas.microsoft.com/office/powerpoint/2010/main" val="1171793747"/>
       </p:ext>
     </p:extLst>
   </p:cSld>
@@ -4307,7 +4307,7 @@
           <p:cNvPr id="1" name="slide-title">
             <a:extLst xmlns:a="http://schemas.openxmlformats.org/drawingml/2006/main">
               <a:ext uri="{FF2B5EF4-FFF2-40B4-BE49-F238E27FC236}">
-                <a16:creationId xmlns:a16="http://schemas.microsoft.com/office/drawing/2014/main" id="{EA90F7FB-15E7-40E2-B222-D67B788F521B}"/>
+                <a16:creationId xmlns:a16="http://schemas.microsoft.com/office/drawing/2014/main" id="{1B68DC8B-FBA8-4406-B036-D2D03C41D652}"/>
               </a:ext>
             </a:extLst>
           </p:cNvPr>
@@ -4352,7 +4352,7 @@
           <p:cNvPr id="2" name="">
             <a:extLst xmlns:a="http://schemas.openxmlformats.org/drawingml/2006/main">
               <a:ext uri="{FF2B5EF4-FFF2-40B4-BE49-F238E27FC236}">
-                <a16:creationId xmlns:a16="http://schemas.microsoft.com/office/drawing/2014/main" id="{7936ECE7-8F8C-433D-A9CF-0911DC26CFE6}"/>
+                <a16:creationId xmlns:a16="http://schemas.microsoft.com/office/drawing/2014/main" id="{452C1FA5-440F-44E5-9773-036BD87E936C}"/>
               </a:ext>
             </a:extLst>
           </p:cNvPr>
@@ -4385,7 +4385,7 @@
           <p:cNvPr id="3" name="">
             <a:extLst xmlns:a="http://schemas.openxmlformats.org/drawingml/2006/main">
               <a:ext uri="{FF2B5EF4-FFF2-40B4-BE49-F238E27FC236}">
-                <a16:creationId xmlns:a16="http://schemas.microsoft.com/office/drawing/2014/main" id="{518F5A46-C4F9-4198-9094-E0FD0E2D61AF}"/>
+                <a16:creationId xmlns:a16="http://schemas.microsoft.com/office/drawing/2014/main" id="{95BA0645-51DB-4E8F-A06D-F62AA6FC80B6}"/>
               </a:ext>
             </a:extLst>
           </p:cNvPr>
@@ -4412,7 +4412,7 @@
           <p:cNvPr id="4" name="">
             <a:extLst xmlns:a="http://schemas.openxmlformats.org/drawingml/2006/main">
               <a:ext uri="{FF2B5EF4-FFF2-40B4-BE49-F238E27FC236}">
-                <a16:creationId xmlns:a16="http://schemas.microsoft.com/office/drawing/2014/main" id="{D33642FA-7625-4A37-ABE3-87C530AB68FA}"/>
+                <a16:creationId xmlns:a16="http://schemas.microsoft.com/office/drawing/2014/main" id="{3ECEBB6E-656E-45E5-BC89-B9E1F19E442B}"/>
               </a:ext>
             </a:extLst>
           </p:cNvPr>
@@ -4457,7 +4457,7 @@
           <p:cNvPr id="5" name="">
             <a:extLst xmlns:a="http://schemas.openxmlformats.org/drawingml/2006/main">
               <a:ext uri="{FF2B5EF4-FFF2-40B4-BE49-F238E27FC236}">
-                <a16:creationId xmlns:a16="http://schemas.microsoft.com/office/drawing/2014/main" id="{96D90C18-DB79-494B-AA00-36219C395677}"/>
+                <a16:creationId xmlns:a16="http://schemas.microsoft.com/office/drawing/2014/main" id="{165ADB39-A9EE-45B9-9AD9-CA34C2E5570F}"/>
               </a:ext>
             </a:extLst>
           </p:cNvPr>
@@ -4484,7 +4484,7 @@
           <p:cNvPr id="6" name="">
             <a:extLst xmlns:a="http://schemas.openxmlformats.org/drawingml/2006/main">
               <a:ext uri="{FF2B5EF4-FFF2-40B4-BE49-F238E27FC236}">
-                <a16:creationId xmlns:a16="http://schemas.microsoft.com/office/drawing/2014/main" id="{B08C8D9A-B560-4D8F-824B-9322AA6882E8}"/>
+                <a16:creationId xmlns:a16="http://schemas.microsoft.com/office/drawing/2014/main" id="{9B20C027-BC10-46B6-9923-1E6A739E35B3}"/>
               </a:ext>
             </a:extLst>
           </p:cNvPr>
@@ -4529,7 +4529,7 @@
           <p:cNvPr id="7" name="">
             <a:extLst xmlns:a="http://schemas.openxmlformats.org/drawingml/2006/main">
               <a:ext uri="{FF2B5EF4-FFF2-40B4-BE49-F238E27FC236}">
-                <a16:creationId xmlns:a16="http://schemas.microsoft.com/office/drawing/2014/main" id="{AEFC500D-5A67-4AEE-8939-FD1FADE2B2EF}"/>
+                <a16:creationId xmlns:a16="http://schemas.microsoft.com/office/drawing/2014/main" id="{C7EB35D9-3F70-48AE-BC63-A4CB07262B4F}"/>
               </a:ext>
             </a:extLst>
           </p:cNvPr>
@@ -4556,7 +4556,7 @@
           <p:cNvPr id="8" name="">
             <a:extLst xmlns:a="http://schemas.openxmlformats.org/drawingml/2006/main">
               <a:ext uri="{FF2B5EF4-FFF2-40B4-BE49-F238E27FC236}">
-                <a16:creationId xmlns:a16="http://schemas.microsoft.com/office/drawing/2014/main" id="{739AC5BC-A9CE-4988-B0EE-F71908A9FA3A}"/>
+                <a16:creationId xmlns:a16="http://schemas.microsoft.com/office/drawing/2014/main" id="{66A45487-9A5C-49E2-8B87-9C27024133C7}"/>
               </a:ext>
             </a:extLst>
           </p:cNvPr>
@@ -4599,7 +4599,7 @@
     </p:spTree>
     <p:extLst>
       <p:ext uri="{BB962C8B-B14F-4D97-AF65-F5344CB8AC3E}">
-        <p14:creationId xmlns:p14="http://schemas.microsoft.com/office/powerpoint/2010/main" val="123129527"/>
+        <p14:creationId xmlns:p14="http://schemas.microsoft.com/office/powerpoint/2010/main" val="480916474"/>
       </p:ext>
     </p:extLst>
   </p:cSld>
@@ -4623,7 +4623,7 @@
           <p:cNvPr id="1" name="slide-title">
             <a:extLst xmlns:a="http://schemas.openxmlformats.org/drawingml/2006/main">
               <a:ext uri="{FF2B5EF4-FFF2-40B4-BE49-F238E27FC236}">
-                <a16:creationId xmlns:a16="http://schemas.microsoft.com/office/drawing/2014/main" id="{F3282061-1AD3-457C-85F5-E4057F46798B}"/>
+                <a16:creationId xmlns:a16="http://schemas.microsoft.com/office/drawing/2014/main" id="{6C32C097-0039-467B-8D9A-E01A876101BA}"/>
               </a:ext>
             </a:extLst>
           </p:cNvPr>
@@ -4668,7 +4668,7 @@
           <p:cNvPr id="2" name="">
             <a:extLst xmlns:a="http://schemas.openxmlformats.org/drawingml/2006/main">
               <a:ext uri="{FF2B5EF4-FFF2-40B4-BE49-F238E27FC236}">
-                <a16:creationId xmlns:a16="http://schemas.microsoft.com/office/drawing/2014/main" id="{2C49AB81-F86B-432B-948F-E46A127733CE}"/>
+                <a16:creationId xmlns:a16="http://schemas.microsoft.com/office/drawing/2014/main" id="{1F4A2068-1D4A-4D14-89D0-13E2CFDF505D}"/>
               </a:ext>
             </a:extLst>
           </p:cNvPr>
@@ -4701,7 +4701,7 @@
           <p:cNvPr id="3" name="">
             <a:extLst xmlns:a="http://schemas.openxmlformats.org/drawingml/2006/main">
               <a:ext uri="{FF2B5EF4-FFF2-40B4-BE49-F238E27FC236}">
-                <a16:creationId xmlns:a16="http://schemas.microsoft.com/office/drawing/2014/main" id="{814500AF-C06F-47DC-8B0A-9CCE3B598891}"/>
+                <a16:creationId xmlns:a16="http://schemas.microsoft.com/office/drawing/2014/main" id="{06B26A06-967A-4EF8-A2B6-040274B04D14}"/>
               </a:ext>
             </a:extLst>
           </p:cNvPr>
@@ -4728,7 +4728,7 @@
           <p:cNvPr id="4" name="">
             <a:extLst xmlns:a="http://schemas.openxmlformats.org/drawingml/2006/main">
               <a:ext uri="{FF2B5EF4-FFF2-40B4-BE49-F238E27FC236}">
-                <a16:creationId xmlns:a16="http://schemas.microsoft.com/office/drawing/2014/main" id="{1C43F504-3534-46C3-AE9A-828C212DFB72}"/>
+                <a16:creationId xmlns:a16="http://schemas.microsoft.com/office/drawing/2014/main" id="{C0260A79-5EA2-4A13-BFC5-443D46CB67AC}"/>
               </a:ext>
             </a:extLst>
           </p:cNvPr>
@@ -4773,7 +4773,7 @@
           <p:cNvPr id="5" name="">
             <a:extLst xmlns:a="http://schemas.openxmlformats.org/drawingml/2006/main">
               <a:ext uri="{FF2B5EF4-FFF2-40B4-BE49-F238E27FC236}">
-                <a16:creationId xmlns:a16="http://schemas.microsoft.com/office/drawing/2014/main" id="{99E37B4B-773C-4BF5-8369-EAD8193DB95C}"/>
+                <a16:creationId xmlns:a16="http://schemas.microsoft.com/office/drawing/2014/main" id="{44079F9F-DB52-494A-99B5-DECA0911F5BE}"/>
               </a:ext>
             </a:extLst>
           </p:cNvPr>
@@ -4800,7 +4800,7 @@
           <p:cNvPr id="6" name="">
             <a:extLst xmlns:a="http://schemas.openxmlformats.org/drawingml/2006/main">
               <a:ext uri="{FF2B5EF4-FFF2-40B4-BE49-F238E27FC236}">
-                <a16:creationId xmlns:a16="http://schemas.microsoft.com/office/drawing/2014/main" id="{0CC5CD0A-C6B7-403A-ABFF-B1D5D0724D2D}"/>
+                <a16:creationId xmlns:a16="http://schemas.microsoft.com/office/drawing/2014/main" id="{44192102-39FE-491D-96BF-6A36F1939651}"/>
               </a:ext>
             </a:extLst>
           </p:cNvPr>
@@ -4845,7 +4845,7 @@
           <p:cNvPr id="7" name="">
             <a:extLst xmlns:a="http://schemas.openxmlformats.org/drawingml/2006/main">
               <a:ext uri="{FF2B5EF4-FFF2-40B4-BE49-F238E27FC236}">
-                <a16:creationId xmlns:a16="http://schemas.microsoft.com/office/drawing/2014/main" id="{DEC1623A-43CA-43D2-9048-33AA565278BA}"/>
+                <a16:creationId xmlns:a16="http://schemas.microsoft.com/office/drawing/2014/main" id="{3F3B94BA-B76F-41B1-8110-3CFA597E4B84}"/>
               </a:ext>
             </a:extLst>
           </p:cNvPr>
@@ -4872,7 +4872,7 @@
           <p:cNvPr id="8" name="">
             <a:extLst xmlns:a="http://schemas.openxmlformats.org/drawingml/2006/main">
               <a:ext uri="{FF2B5EF4-FFF2-40B4-BE49-F238E27FC236}">
-                <a16:creationId xmlns:a16="http://schemas.microsoft.com/office/drawing/2014/main" id="{117537B3-643D-4195-86CB-E29A91C0C79E}"/>
+                <a16:creationId xmlns:a16="http://schemas.microsoft.com/office/drawing/2014/main" id="{3EDBCDBB-92B7-44EE-A5F5-41570936F606}"/>
               </a:ext>
             </a:extLst>
           </p:cNvPr>
@@ -4917,7 +4917,7 @@
           <p:cNvPr id="9" name="">
             <a:extLst xmlns:a="http://schemas.openxmlformats.org/drawingml/2006/main">
               <a:ext uri="{FF2B5EF4-FFF2-40B4-BE49-F238E27FC236}">
-                <a16:creationId xmlns:a16="http://schemas.microsoft.com/office/drawing/2014/main" id="{0F5CA1DF-653C-4BC9-93C2-ACECE2F0098D}"/>
+                <a16:creationId xmlns:a16="http://schemas.microsoft.com/office/drawing/2014/main" id="{F46212B4-6844-492E-AEF9-9778CFDDB05F}"/>
               </a:ext>
             </a:extLst>
           </p:cNvPr>
@@ -4944,7 +4944,7 @@
           <p:cNvPr id="10" name="">
             <a:extLst xmlns:a="http://schemas.openxmlformats.org/drawingml/2006/main">
               <a:ext uri="{FF2B5EF4-FFF2-40B4-BE49-F238E27FC236}">
-                <a16:creationId xmlns:a16="http://schemas.microsoft.com/office/drawing/2014/main" id="{1AC94858-1FE2-4576-A734-B8306FEFA12C}"/>
+                <a16:creationId xmlns:a16="http://schemas.microsoft.com/office/drawing/2014/main" id="{21E803F3-6876-4279-A133-077EC849FF0A}"/>
               </a:ext>
             </a:extLst>
           </p:cNvPr>
@@ -4987,7 +4987,7 @@
     </p:spTree>
     <p:extLst>
       <p:ext uri="{BB962C8B-B14F-4D97-AF65-F5344CB8AC3E}">
-        <p14:creationId xmlns:p14="http://schemas.microsoft.com/office/powerpoint/2010/main" val="898950276"/>
+        <p14:creationId xmlns:p14="http://schemas.microsoft.com/office/powerpoint/2010/main" val="349080219"/>
       </p:ext>
     </p:extLst>
   </p:cSld>
@@ -5011,7 +5011,7 @@
           <p:cNvPr id="1" name="slide-title">
             <a:extLst xmlns:a="http://schemas.openxmlformats.org/drawingml/2006/main">
               <a:ext uri="{FF2B5EF4-FFF2-40B4-BE49-F238E27FC236}">
-                <a16:creationId xmlns:a16="http://schemas.microsoft.com/office/drawing/2014/main" id="{17017D41-24B0-46D7-A517-98158C73C4BA}"/>
+                <a16:creationId xmlns:a16="http://schemas.microsoft.com/office/drawing/2014/main" id="{51CB005A-5AD0-49C4-80C2-466776136D7D}"/>
               </a:ext>
             </a:extLst>
           </p:cNvPr>
@@ -5056,7 +5056,7 @@
           <p:cNvPr id="2" name="">
             <a:extLst xmlns:a="http://schemas.openxmlformats.org/drawingml/2006/main">
               <a:ext uri="{FF2B5EF4-FFF2-40B4-BE49-F238E27FC236}">
-                <a16:creationId xmlns:a16="http://schemas.microsoft.com/office/drawing/2014/main" id="{417CA3C1-4080-43C7-BC9D-131855CE52FF}"/>
+                <a16:creationId xmlns:a16="http://schemas.microsoft.com/office/drawing/2014/main" id="{A46043AB-A726-4E71-BD6F-CEF8E80C743D}"/>
               </a:ext>
             </a:extLst>
           </p:cNvPr>
@@ -5089,7 +5089,7 @@
           <p:cNvPr id="3" name="">
             <a:extLst xmlns:a="http://schemas.openxmlformats.org/drawingml/2006/main">
               <a:ext uri="{FF2B5EF4-FFF2-40B4-BE49-F238E27FC236}">
-                <a16:creationId xmlns:a16="http://schemas.microsoft.com/office/drawing/2014/main" id="{771C48B5-AC4E-4D37-BEB3-EF12BA84FE8A}"/>
+                <a16:creationId xmlns:a16="http://schemas.microsoft.com/office/drawing/2014/main" id="{5A253070-9B36-4139-97E7-DE401B0A67BC}"/>
               </a:ext>
             </a:extLst>
           </p:cNvPr>
@@ -5116,7 +5116,7 @@
           <p:cNvPr id="4" name="">
             <a:extLst xmlns:a="http://schemas.openxmlformats.org/drawingml/2006/main">
               <a:ext uri="{FF2B5EF4-FFF2-40B4-BE49-F238E27FC236}">
-                <a16:creationId xmlns:a16="http://schemas.microsoft.com/office/drawing/2014/main" id="{A89CCD43-88DD-4BFE-B204-50BCD13F4D56}"/>
+                <a16:creationId xmlns:a16="http://schemas.microsoft.com/office/drawing/2014/main" id="{1D79A731-39E6-42C4-942A-1F7AC1EBBE55}"/>
               </a:ext>
             </a:extLst>
           </p:cNvPr>
@@ -5161,7 +5161,7 @@
           <p:cNvPr id="5" name="">
             <a:extLst xmlns:a="http://schemas.openxmlformats.org/drawingml/2006/main">
               <a:ext uri="{FF2B5EF4-FFF2-40B4-BE49-F238E27FC236}">
-                <a16:creationId xmlns:a16="http://schemas.microsoft.com/office/drawing/2014/main" id="{AA128FE8-41D9-49D0-BA60-EAB215C12A45}"/>
+                <a16:creationId xmlns:a16="http://schemas.microsoft.com/office/drawing/2014/main" id="{D8EA95D4-22A7-458E-BCEA-BDF6682A883F}"/>
               </a:ext>
             </a:extLst>
           </p:cNvPr>
@@ -5188,7 +5188,7 @@
           <p:cNvPr id="6" name="">
             <a:extLst xmlns:a="http://schemas.openxmlformats.org/drawingml/2006/main">
               <a:ext uri="{FF2B5EF4-FFF2-40B4-BE49-F238E27FC236}">
-                <a16:creationId xmlns:a16="http://schemas.microsoft.com/office/drawing/2014/main" id="{CB2BA261-CA75-49F5-9067-8096B006B10E}"/>
+                <a16:creationId xmlns:a16="http://schemas.microsoft.com/office/drawing/2014/main" id="{8FB18AEE-B53E-414A-A9D7-21A15F54CFA4}"/>
               </a:ext>
             </a:extLst>
           </p:cNvPr>
@@ -5233,7 +5233,7 @@
           <p:cNvPr id="7" name="">
             <a:extLst xmlns:a="http://schemas.openxmlformats.org/drawingml/2006/main">
               <a:ext uri="{FF2B5EF4-FFF2-40B4-BE49-F238E27FC236}">
-                <a16:creationId xmlns:a16="http://schemas.microsoft.com/office/drawing/2014/main" id="{594EF122-5574-4248-A9B2-152151FEDE49}"/>
+                <a16:creationId xmlns:a16="http://schemas.microsoft.com/office/drawing/2014/main" id="{CBF594A1-F15E-4B7E-B12F-2FD06108F482}"/>
               </a:ext>
             </a:extLst>
           </p:cNvPr>
@@ -5260,7 +5260,7 @@
           <p:cNvPr id="8" name="">
             <a:extLst xmlns:a="http://schemas.openxmlformats.org/drawingml/2006/main">
               <a:ext uri="{FF2B5EF4-FFF2-40B4-BE49-F238E27FC236}">
-                <a16:creationId xmlns:a16="http://schemas.microsoft.com/office/drawing/2014/main" id="{7D3959D0-04CF-46F4-8479-A4013D4274D5}"/>
+                <a16:creationId xmlns:a16="http://schemas.microsoft.com/office/drawing/2014/main" id="{425748B2-91CD-4C46-91D9-ADF9B1CBFD7D}"/>
               </a:ext>
             </a:extLst>
           </p:cNvPr>
@@ -5305,7 +5305,7 @@
           <p:cNvPr id="9" name="">
             <a:extLst xmlns:a="http://schemas.openxmlformats.org/drawingml/2006/main">
               <a:ext uri="{FF2B5EF4-FFF2-40B4-BE49-F238E27FC236}">
-                <a16:creationId xmlns:a16="http://schemas.microsoft.com/office/drawing/2014/main" id="{C6F016D7-9D5D-4106-A9E3-1E89097D4083}"/>
+                <a16:creationId xmlns:a16="http://schemas.microsoft.com/office/drawing/2014/main" id="{DCC3F8DB-713C-4DD9-A31E-251A64411E04}"/>
               </a:ext>
             </a:extLst>
           </p:cNvPr>
@@ -5332,7 +5332,7 @@
           <p:cNvPr id="10" name="">
             <a:extLst xmlns:a="http://schemas.openxmlformats.org/drawingml/2006/main">
               <a:ext uri="{FF2B5EF4-FFF2-40B4-BE49-F238E27FC236}">
-                <a16:creationId xmlns:a16="http://schemas.microsoft.com/office/drawing/2014/main" id="{803AD20F-5CB5-452C-A5AE-3AA6E1052BDA}"/>
+                <a16:creationId xmlns:a16="http://schemas.microsoft.com/office/drawing/2014/main" id="{6B2D03C3-88C8-48E6-BCAA-68CBC9292B36}"/>
               </a:ext>
             </a:extLst>
           </p:cNvPr>
@@ -5375,7 +5375,7 @@
     </p:spTree>
     <p:extLst>
       <p:ext uri="{BB962C8B-B14F-4D97-AF65-F5344CB8AC3E}">
-        <p14:creationId xmlns:p14="http://schemas.microsoft.com/office/powerpoint/2010/main" val="253163643"/>
+        <p14:creationId xmlns:p14="http://schemas.microsoft.com/office/powerpoint/2010/main" val="263173391"/>
       </p:ext>
     </p:extLst>
   </p:cSld>
@@ -5399,7 +5399,7 @@
           <p:cNvPr id="1" name="slide-title">
             <a:extLst xmlns:a="http://schemas.openxmlformats.org/drawingml/2006/main">
               <a:ext uri="{FF2B5EF4-FFF2-40B4-BE49-F238E27FC236}">
-                <a16:creationId xmlns:a16="http://schemas.microsoft.com/office/drawing/2014/main" id="{13193846-6334-4920-8A4D-F957A5170D5E}"/>
+                <a16:creationId xmlns:a16="http://schemas.microsoft.com/office/drawing/2014/main" id="{51B7F99E-1679-42C0-9AA6-0C16D3042186}"/>
               </a:ext>
             </a:extLst>
           </p:cNvPr>
@@ -5444,7 +5444,7 @@
           <p:cNvPr id="2" name="">
             <a:extLst xmlns:a="http://schemas.openxmlformats.org/drawingml/2006/main">
               <a:ext uri="{FF2B5EF4-FFF2-40B4-BE49-F238E27FC236}">
-                <a16:creationId xmlns:a16="http://schemas.microsoft.com/office/drawing/2014/main" id="{1852C1AC-D75A-4EAB-A619-9548863A071C}"/>
+                <a16:creationId xmlns:a16="http://schemas.microsoft.com/office/drawing/2014/main" id="{57437C1B-EB67-4613-9EBC-24EDC2E0B003}"/>
               </a:ext>
             </a:extLst>
           </p:cNvPr>
@@ -5477,7 +5477,7 @@
           <p:cNvPr id="3" name="">
             <a:extLst xmlns:a="http://schemas.openxmlformats.org/drawingml/2006/main">
               <a:ext uri="{FF2B5EF4-FFF2-40B4-BE49-F238E27FC236}">
-                <a16:creationId xmlns:a16="http://schemas.microsoft.com/office/drawing/2014/main" id="{404D4489-1AE8-4C22-8374-51D52EA211BD}"/>
+                <a16:creationId xmlns:a16="http://schemas.microsoft.com/office/drawing/2014/main" id="{794E81EC-44BE-491D-817D-A2AD09D93F35}"/>
               </a:ext>
             </a:extLst>
           </p:cNvPr>
@@ -5504,7 +5504,7 @@
           <p:cNvPr id="4" name="">
             <a:extLst xmlns:a="http://schemas.openxmlformats.org/drawingml/2006/main">
               <a:ext uri="{FF2B5EF4-FFF2-40B4-BE49-F238E27FC236}">
-                <a16:creationId xmlns:a16="http://schemas.microsoft.com/office/drawing/2014/main" id="{CAEA43AD-C168-404F-83C3-DD3E7A59F586}"/>
+                <a16:creationId xmlns:a16="http://schemas.microsoft.com/office/drawing/2014/main" id="{AEDF5E52-3E42-4765-918D-2F99837C2EFD}"/>
               </a:ext>
             </a:extLst>
           </p:cNvPr>
@@ -5549,7 +5549,7 @@
           <p:cNvPr id="5" name="">
             <a:extLst xmlns:a="http://schemas.openxmlformats.org/drawingml/2006/main">
               <a:ext uri="{FF2B5EF4-FFF2-40B4-BE49-F238E27FC236}">
-                <a16:creationId xmlns:a16="http://schemas.microsoft.com/office/drawing/2014/main" id="{FA509DEF-1C76-49E1-8304-7C97CE5EA859}"/>
+                <a16:creationId xmlns:a16="http://schemas.microsoft.com/office/drawing/2014/main" id="{5A752641-08AF-4B82-9C4A-AB5F39176EB3}"/>
               </a:ext>
             </a:extLst>
           </p:cNvPr>
@@ -5576,7 +5576,7 @@
           <p:cNvPr id="6" name="">
             <a:extLst xmlns:a="http://schemas.openxmlformats.org/drawingml/2006/main">
               <a:ext uri="{FF2B5EF4-FFF2-40B4-BE49-F238E27FC236}">
-                <a16:creationId xmlns:a16="http://schemas.microsoft.com/office/drawing/2014/main" id="{3B64D603-2E59-4F21-9151-D1C25682DE0C}"/>
+                <a16:creationId xmlns:a16="http://schemas.microsoft.com/office/drawing/2014/main" id="{7299451E-5A76-4CFD-880F-A6B6CCEEA1A6}"/>
               </a:ext>
             </a:extLst>
           </p:cNvPr>
@@ -5621,7 +5621,7 @@
           <p:cNvPr id="7" name="">
             <a:extLst xmlns:a="http://schemas.openxmlformats.org/drawingml/2006/main">
               <a:ext uri="{FF2B5EF4-FFF2-40B4-BE49-F238E27FC236}">
-                <a16:creationId xmlns:a16="http://schemas.microsoft.com/office/drawing/2014/main" id="{C4CDFD92-9575-4BB4-BD84-D2D25AA026F3}"/>
+                <a16:creationId xmlns:a16="http://schemas.microsoft.com/office/drawing/2014/main" id="{2947EF75-093E-4012-BD48-6AA7B54F33DB}"/>
               </a:ext>
             </a:extLst>
           </p:cNvPr>
@@ -5648,7 +5648,7 @@
           <p:cNvPr id="8" name="">
             <a:extLst xmlns:a="http://schemas.openxmlformats.org/drawingml/2006/main">
               <a:ext uri="{FF2B5EF4-FFF2-40B4-BE49-F238E27FC236}">
-                <a16:creationId xmlns:a16="http://schemas.microsoft.com/office/drawing/2014/main" id="{8DA58948-D2CD-4594-8951-C0BD12F0A8A4}"/>
+                <a16:creationId xmlns:a16="http://schemas.microsoft.com/office/drawing/2014/main" id="{EEE83067-2421-4C6B-84A3-04831F4B3914}"/>
               </a:ext>
             </a:extLst>
           </p:cNvPr>
@@ -5693,7 +5693,7 @@
           <p:cNvPr id="9" name="">
             <a:extLst xmlns:a="http://schemas.openxmlformats.org/drawingml/2006/main">
               <a:ext uri="{FF2B5EF4-FFF2-40B4-BE49-F238E27FC236}">
-                <a16:creationId xmlns:a16="http://schemas.microsoft.com/office/drawing/2014/main" id="{0AC52FCB-EC69-4570-934C-641860AD74BF}"/>
+                <a16:creationId xmlns:a16="http://schemas.microsoft.com/office/drawing/2014/main" id="{8915B61A-B6CF-4485-9A5A-D544248BE904}"/>
               </a:ext>
             </a:extLst>
           </p:cNvPr>
@@ -5720,7 +5720,7 @@
           <p:cNvPr id="10" name="">
             <a:extLst xmlns:a="http://schemas.openxmlformats.org/drawingml/2006/main">
               <a:ext uri="{FF2B5EF4-FFF2-40B4-BE49-F238E27FC236}">
-                <a16:creationId xmlns:a16="http://schemas.microsoft.com/office/drawing/2014/main" id="{F324840B-71B1-4242-B5C7-6683DEC1894A}"/>
+                <a16:creationId xmlns:a16="http://schemas.microsoft.com/office/drawing/2014/main" id="{F620FD07-399E-4388-B427-03939C6138CF}"/>
               </a:ext>
             </a:extLst>
           </p:cNvPr>
@@ -5763,7 +5763,7 @@
     </p:spTree>
     <p:extLst>
       <p:ext uri="{BB962C8B-B14F-4D97-AF65-F5344CB8AC3E}">
-        <p14:creationId xmlns:p14="http://schemas.microsoft.com/office/powerpoint/2010/main" val="750823468"/>
+        <p14:creationId xmlns:p14="http://schemas.microsoft.com/office/powerpoint/2010/main" val="1116837811"/>
       </p:ext>
     </p:extLst>
   </p:cSld>
@@ -5787,7 +5787,7 @@
           <p:cNvPr id="1" name="slide-title">
             <a:extLst xmlns:a="http://schemas.openxmlformats.org/drawingml/2006/main">
               <a:ext uri="{FF2B5EF4-FFF2-40B4-BE49-F238E27FC236}">
-                <a16:creationId xmlns:a16="http://schemas.microsoft.com/office/drawing/2014/main" id="{0D97858E-4F65-43CF-81AF-7F9D2B61F3BA}"/>
+                <a16:creationId xmlns:a16="http://schemas.microsoft.com/office/drawing/2014/main" id="{8D773814-D405-4477-8A68-B137C71FDB48}"/>
               </a:ext>
             </a:extLst>
           </p:cNvPr>
@@ -5832,7 +5832,7 @@
           <p:cNvPr id="2" name="">
             <a:extLst xmlns:a="http://schemas.openxmlformats.org/drawingml/2006/main">
               <a:ext uri="{FF2B5EF4-FFF2-40B4-BE49-F238E27FC236}">
-                <a16:creationId xmlns:a16="http://schemas.microsoft.com/office/drawing/2014/main" id="{C02C212C-27AD-4A88-BAE7-EA5D56407610}"/>
+                <a16:creationId xmlns:a16="http://schemas.microsoft.com/office/drawing/2014/main" id="{FD10E424-D7B0-470D-AE2C-E622FAF2BFE7}"/>
               </a:ext>
             </a:extLst>
           </p:cNvPr>
@@ -5865,7 +5865,7 @@
           <p:cNvPr id="3" name="">
             <a:extLst xmlns:a="http://schemas.openxmlformats.org/drawingml/2006/main">
               <a:ext uri="{FF2B5EF4-FFF2-40B4-BE49-F238E27FC236}">
-                <a16:creationId xmlns:a16="http://schemas.microsoft.com/office/drawing/2014/main" id="{73F3BE41-3819-4A84-9C45-743D773C3EED}"/>
+                <a16:creationId xmlns:a16="http://schemas.microsoft.com/office/drawing/2014/main" id="{7903B2DF-8E26-4006-A0A0-F7DEB3B950C1}"/>
               </a:ext>
             </a:extLst>
           </p:cNvPr>
@@ -5892,7 +5892,7 @@
           <p:cNvPr id="4" name="">
             <a:extLst xmlns:a="http://schemas.openxmlformats.org/drawingml/2006/main">
               <a:ext uri="{FF2B5EF4-FFF2-40B4-BE49-F238E27FC236}">
-                <a16:creationId xmlns:a16="http://schemas.microsoft.com/office/drawing/2014/main" id="{E1915B25-911F-4493-B40A-9270C128FBCB}"/>
+                <a16:creationId xmlns:a16="http://schemas.microsoft.com/office/drawing/2014/main" id="{8CE8C590-B12C-4411-908A-18120885F45F}"/>
               </a:ext>
             </a:extLst>
           </p:cNvPr>
@@ -5937,7 +5937,7 @@
           <p:cNvPr id="5" name="">
             <a:extLst xmlns:a="http://schemas.openxmlformats.org/drawingml/2006/main">
               <a:ext uri="{FF2B5EF4-FFF2-40B4-BE49-F238E27FC236}">
-                <a16:creationId xmlns:a16="http://schemas.microsoft.com/office/drawing/2014/main" id="{6638B7F1-9AD9-4490-A60C-5FAFF9FB9CF1}"/>
+                <a16:creationId xmlns:a16="http://schemas.microsoft.com/office/drawing/2014/main" id="{F10FCC86-94B7-459C-9E66-6FE1689948F1}"/>
               </a:ext>
             </a:extLst>
           </p:cNvPr>
@@ -5964,7 +5964,7 @@
           <p:cNvPr id="6" name="">
             <a:extLst xmlns:a="http://schemas.openxmlformats.org/drawingml/2006/main">
               <a:ext uri="{FF2B5EF4-FFF2-40B4-BE49-F238E27FC236}">
-                <a16:creationId xmlns:a16="http://schemas.microsoft.com/office/drawing/2014/main" id="{D0B903D3-36DA-4CC5-A9EB-C36F2C80943E}"/>
+                <a16:creationId xmlns:a16="http://schemas.microsoft.com/office/drawing/2014/main" id="{B5AB7CCD-3178-497F-A2D1-BA208724D72C}"/>
               </a:ext>
             </a:extLst>
           </p:cNvPr>
@@ -6009,7 +6009,7 @@
           <p:cNvPr id="7" name="">
             <a:extLst xmlns:a="http://schemas.openxmlformats.org/drawingml/2006/main">
               <a:ext uri="{FF2B5EF4-FFF2-40B4-BE49-F238E27FC236}">
-                <a16:creationId xmlns:a16="http://schemas.microsoft.com/office/drawing/2014/main" id="{1B08B108-3CCA-4CE1-9A26-7529589FB663}"/>
+                <a16:creationId xmlns:a16="http://schemas.microsoft.com/office/drawing/2014/main" id="{5FC0F41D-B973-4009-808F-62CBB4B95BA0}"/>
               </a:ext>
             </a:extLst>
           </p:cNvPr>
@@ -6036,7 +6036,7 @@
           <p:cNvPr id="8" name="">
             <a:extLst xmlns:a="http://schemas.openxmlformats.org/drawingml/2006/main">
               <a:ext uri="{FF2B5EF4-FFF2-40B4-BE49-F238E27FC236}">
-                <a16:creationId xmlns:a16="http://schemas.microsoft.com/office/drawing/2014/main" id="{D200E71F-3B6F-4234-B2B2-33DF981D3C2D}"/>
+                <a16:creationId xmlns:a16="http://schemas.microsoft.com/office/drawing/2014/main" id="{50CAEF7D-39CB-40ED-835A-40E46E454BE1}"/>
               </a:ext>
             </a:extLst>
           </p:cNvPr>
@@ -6081,7 +6081,7 @@
           <p:cNvPr id="9" name="">
             <a:extLst xmlns:a="http://schemas.openxmlformats.org/drawingml/2006/main">
               <a:ext uri="{FF2B5EF4-FFF2-40B4-BE49-F238E27FC236}">
-                <a16:creationId xmlns:a16="http://schemas.microsoft.com/office/drawing/2014/main" id="{70584E3C-116A-4D4A-9223-2F2EAE6C6FD7}"/>
+                <a16:creationId xmlns:a16="http://schemas.microsoft.com/office/drawing/2014/main" id="{39D8DA3B-A578-40E6-9D38-639774871B0F}"/>
               </a:ext>
             </a:extLst>
           </p:cNvPr>
@@ -6108,7 +6108,7 @@
           <p:cNvPr id="10" name="">
             <a:extLst xmlns:a="http://schemas.openxmlformats.org/drawingml/2006/main">
               <a:ext uri="{FF2B5EF4-FFF2-40B4-BE49-F238E27FC236}">
-                <a16:creationId xmlns:a16="http://schemas.microsoft.com/office/drawing/2014/main" id="{8810B1B8-4F9A-42A7-B879-73833DF3791D}"/>
+                <a16:creationId xmlns:a16="http://schemas.microsoft.com/office/drawing/2014/main" id="{D9DCC02E-44E8-4C08-B87E-9E9F55FFD4A8}"/>
               </a:ext>
             </a:extLst>
           </p:cNvPr>
@@ -6151,7 +6151,7 @@
     </p:spTree>
     <p:extLst>
       <p:ext uri="{BB962C8B-B14F-4D97-AF65-F5344CB8AC3E}">
-        <p14:creationId xmlns:p14="http://schemas.microsoft.com/office/powerpoint/2010/main" val="1200364488"/>
+        <p14:creationId xmlns:p14="http://schemas.microsoft.com/office/powerpoint/2010/main" val="856365052"/>
       </p:ext>
     </p:extLst>
   </p:cSld>

</xml_diff>

<commit_message>
Add Tableau dashboard deliverable: .twbx, screenshots, updated report and presentation
</commit_message>
<xml_diff>
--- a/reports/presentation.pptx
+++ b/reports/presentation.pptx
@@ -1708,6 +1708,10 @@
             <a:prstDash val="solid"/>
           </a:ln>
         </p:spPr>
+        <p:txBody xmlns:a="http://schemas.openxmlformats.org/drawingml/2006/main">
+          <a:bodyPr/>
+          <a:p/>
+        </p:txBody>
       </p:sp>
       <p:sp>
         <p:nvSpPr>
@@ -1870,6 +1874,10 @@
           </a:prstGeom>
           <a:noFill xmlns:a="http://schemas.openxmlformats.org/drawingml/2006/main"/>
         </p:spPr>
+        <p:txBody xmlns:a="http://schemas.openxmlformats.org/drawingml/2006/main">
+          <a:bodyPr/>
+          <a:p/>
+        </p:txBody>
       </p:sp>
       <p:sp>
         <p:nvSpPr>
@@ -2195,6 +2203,10 @@
             <a:prstDash val="solid"/>
           </a:ln>
         </p:spPr>
+        <p:txBody xmlns:a="http://schemas.openxmlformats.org/drawingml/2006/main">
+          <a:bodyPr/>
+          <a:p/>
+        </p:txBody>
       </p:sp>
       <p:sp>
         <p:nvSpPr>
@@ -2222,6 +2234,10 @@
           </a:prstGeom>
           <a:noFill xmlns:a="http://schemas.openxmlformats.org/drawingml/2006/main"/>
         </p:spPr>
+        <p:txBody xmlns:a="http://schemas.openxmlformats.org/drawingml/2006/main">
+          <a:bodyPr/>
+          <a:p/>
+        </p:txBody>
       </p:sp>
       <p:sp>
         <p:nvSpPr>
@@ -2294,6 +2310,10 @@
           </a:prstGeom>
           <a:noFill xmlns:a="http://schemas.openxmlformats.org/drawingml/2006/main"/>
         </p:spPr>
+        <p:txBody xmlns:a="http://schemas.openxmlformats.org/drawingml/2006/main">
+          <a:bodyPr/>
+          <a:p/>
+        </p:txBody>
       </p:sp>
       <p:sp>
         <p:nvSpPr>
@@ -2366,6 +2386,10 @@
           </a:prstGeom>
           <a:noFill xmlns:a="http://schemas.openxmlformats.org/drawingml/2006/main"/>
         </p:spPr>
+        <p:txBody xmlns:a="http://schemas.openxmlformats.org/drawingml/2006/main">
+          <a:bodyPr/>
+          <a:p/>
+        </p:txBody>
       </p:sp>
       <p:sp>
         <p:nvSpPr>
@@ -2438,6 +2462,10 @@
           </a:prstGeom>
           <a:noFill xmlns:a="http://schemas.openxmlformats.org/drawingml/2006/main"/>
         </p:spPr>
+        <p:txBody xmlns:a="http://schemas.openxmlformats.org/drawingml/2006/main">
+          <a:bodyPr/>
+          <a:p/>
+        </p:txBody>
       </p:sp>
       <p:sp>
         <p:nvSpPr>
@@ -2583,6 +2611,10 @@
             <a:prstDash val="solid"/>
           </a:ln>
         </p:spPr>
+        <p:txBody xmlns:a="http://schemas.openxmlformats.org/drawingml/2006/main">
+          <a:bodyPr/>
+          <a:p/>
+        </p:txBody>
       </p:sp>
       <p:sp>
         <p:nvSpPr>
@@ -2610,6 +2642,10 @@
           </a:prstGeom>
           <a:noFill xmlns:a="http://schemas.openxmlformats.org/drawingml/2006/main"/>
         </p:spPr>
+        <p:txBody xmlns:a="http://schemas.openxmlformats.org/drawingml/2006/main">
+          <a:bodyPr/>
+          <a:p/>
+        </p:txBody>
       </p:sp>
       <p:sp>
         <p:nvSpPr>
@@ -2682,6 +2718,10 @@
           </a:prstGeom>
           <a:noFill xmlns:a="http://schemas.openxmlformats.org/drawingml/2006/main"/>
         </p:spPr>
+        <p:txBody xmlns:a="http://schemas.openxmlformats.org/drawingml/2006/main">
+          <a:bodyPr/>
+          <a:p/>
+        </p:txBody>
       </p:sp>
       <p:sp>
         <p:nvSpPr>
@@ -2754,6 +2794,10 @@
           </a:prstGeom>
           <a:noFill xmlns:a="http://schemas.openxmlformats.org/drawingml/2006/main"/>
         </p:spPr>
+        <p:txBody xmlns:a="http://schemas.openxmlformats.org/drawingml/2006/main">
+          <a:bodyPr/>
+          <a:p/>
+        </p:txBody>
       </p:sp>
       <p:sp>
         <p:nvSpPr>
@@ -2826,6 +2870,10 @@
           </a:prstGeom>
           <a:noFill xmlns:a="http://schemas.openxmlformats.org/drawingml/2006/main"/>
         </p:spPr>
+        <p:txBody xmlns:a="http://schemas.openxmlformats.org/drawingml/2006/main">
+          <a:bodyPr/>
+          <a:p/>
+        </p:txBody>
       </p:sp>
       <p:sp>
         <p:nvSpPr>
@@ -2898,6 +2946,10 @@
           </a:prstGeom>
           <a:noFill xmlns:a="http://schemas.openxmlformats.org/drawingml/2006/main"/>
         </p:spPr>
+        <p:txBody xmlns:a="http://schemas.openxmlformats.org/drawingml/2006/main">
+          <a:bodyPr/>
+          <a:p/>
+        </p:txBody>
       </p:sp>
       <p:sp>
         <p:nvSpPr>
@@ -3043,6 +3095,10 @@
             <a:prstDash val="solid"/>
           </a:ln>
         </p:spPr>
+        <p:txBody xmlns:a="http://schemas.openxmlformats.org/drawingml/2006/main">
+          <a:bodyPr/>
+          <a:p/>
+        </p:txBody>
       </p:sp>
       <p:sp>
         <p:nvSpPr>
@@ -3070,6 +3126,10 @@
           </a:prstGeom>
           <a:noFill xmlns:a="http://schemas.openxmlformats.org/drawingml/2006/main"/>
         </p:spPr>
+        <p:txBody xmlns:a="http://schemas.openxmlformats.org/drawingml/2006/main">
+          <a:bodyPr/>
+          <a:p/>
+        </p:txBody>
       </p:sp>
       <p:sp>
         <p:nvSpPr>
@@ -3142,6 +3202,10 @@
           </a:prstGeom>
           <a:noFill xmlns:a="http://schemas.openxmlformats.org/drawingml/2006/main"/>
         </p:spPr>
+        <p:txBody xmlns:a="http://schemas.openxmlformats.org/drawingml/2006/main">
+          <a:bodyPr/>
+          <a:p/>
+        </p:txBody>
       </p:sp>
       <p:sp>
         <p:nvSpPr>
@@ -3214,6 +3278,10 @@
           </a:prstGeom>
           <a:noFill xmlns:a="http://schemas.openxmlformats.org/drawingml/2006/main"/>
         </p:spPr>
+        <p:txBody xmlns:a="http://schemas.openxmlformats.org/drawingml/2006/main">
+          <a:bodyPr/>
+          <a:p/>
+        </p:txBody>
       </p:sp>
       <p:sp>
         <p:nvSpPr>
@@ -3359,6 +3427,10 @@
             <a:prstDash val="solid"/>
           </a:ln>
         </p:spPr>
+        <p:txBody xmlns:a="http://schemas.openxmlformats.org/drawingml/2006/main">
+          <a:bodyPr/>
+          <a:p/>
+        </p:txBody>
       </p:sp>
       <p:sp>
         <p:nvSpPr>
@@ -3386,6 +3458,10 @@
           </a:prstGeom>
           <a:noFill xmlns:a="http://schemas.openxmlformats.org/drawingml/2006/main"/>
         </p:spPr>
+        <p:txBody xmlns:a="http://schemas.openxmlformats.org/drawingml/2006/main">
+          <a:bodyPr/>
+          <a:p/>
+        </p:txBody>
       </p:sp>
       <p:sp>
         <p:nvSpPr>
@@ -3458,6 +3534,10 @@
           </a:prstGeom>
           <a:noFill xmlns:a="http://schemas.openxmlformats.org/drawingml/2006/main"/>
         </p:spPr>
+        <p:txBody xmlns:a="http://schemas.openxmlformats.org/drawingml/2006/main">
+          <a:bodyPr/>
+          <a:p/>
+        </p:txBody>
       </p:sp>
       <p:sp>
         <p:nvSpPr>
@@ -3530,6 +3610,10 @@
           </a:prstGeom>
           <a:noFill xmlns:a="http://schemas.openxmlformats.org/drawingml/2006/main"/>
         </p:spPr>
+        <p:txBody xmlns:a="http://schemas.openxmlformats.org/drawingml/2006/main">
+          <a:bodyPr/>
+          <a:p/>
+        </p:txBody>
       </p:sp>
       <p:sp>
         <p:nvSpPr>
@@ -3675,6 +3759,10 @@
             <a:prstDash val="solid"/>
           </a:ln>
         </p:spPr>
+        <p:txBody xmlns:a="http://schemas.openxmlformats.org/drawingml/2006/main">
+          <a:bodyPr/>
+          <a:p/>
+        </p:txBody>
       </p:sp>
       <p:sp>
         <p:nvSpPr>
@@ -3702,6 +3790,10 @@
           </a:prstGeom>
           <a:noFill xmlns:a="http://schemas.openxmlformats.org/drawingml/2006/main"/>
         </p:spPr>
+        <p:txBody xmlns:a="http://schemas.openxmlformats.org/drawingml/2006/main">
+          <a:bodyPr/>
+          <a:p/>
+        </p:txBody>
       </p:sp>
       <p:sp>
         <p:nvSpPr>
@@ -3774,6 +3866,10 @@
           </a:prstGeom>
           <a:noFill xmlns:a="http://schemas.openxmlformats.org/drawingml/2006/main"/>
         </p:spPr>
+        <p:txBody xmlns:a="http://schemas.openxmlformats.org/drawingml/2006/main">
+          <a:bodyPr/>
+          <a:p/>
+        </p:txBody>
       </p:sp>
       <p:sp>
         <p:nvSpPr>
@@ -3846,6 +3942,10 @@
           </a:prstGeom>
           <a:noFill xmlns:a="http://schemas.openxmlformats.org/drawingml/2006/main"/>
         </p:spPr>
+        <p:txBody xmlns:a="http://schemas.openxmlformats.org/drawingml/2006/main">
+          <a:bodyPr/>
+          <a:p/>
+        </p:txBody>
       </p:sp>
       <p:sp>
         <p:nvSpPr>
@@ -3918,6 +4018,10 @@
           </a:prstGeom>
           <a:noFill xmlns:a="http://schemas.openxmlformats.org/drawingml/2006/main"/>
         </p:spPr>
+        <p:txBody xmlns:a="http://schemas.openxmlformats.org/drawingml/2006/main">
+          <a:bodyPr/>
+          <a:p/>
+        </p:txBody>
       </p:sp>
       <p:sp>
         <p:nvSpPr>
@@ -4063,6 +4167,10 @@
             <a:prstDash val="solid"/>
           </a:ln>
         </p:spPr>
+        <p:txBody xmlns:a="http://schemas.openxmlformats.org/drawingml/2006/main">
+          <a:bodyPr/>
+          <a:p/>
+        </p:txBody>
       </p:sp>
       <p:sp>
         <p:nvSpPr>
@@ -4090,6 +4198,10 @@
           </a:prstGeom>
           <a:noFill xmlns:a="http://schemas.openxmlformats.org/drawingml/2006/main"/>
         </p:spPr>
+        <p:txBody xmlns:a="http://schemas.openxmlformats.org/drawingml/2006/main">
+          <a:bodyPr/>
+          <a:p/>
+        </p:txBody>
       </p:sp>
       <p:sp>
         <p:nvSpPr>
@@ -4162,6 +4274,10 @@
           </a:prstGeom>
           <a:noFill xmlns:a="http://schemas.openxmlformats.org/drawingml/2006/main"/>
         </p:spPr>
+        <p:txBody xmlns:a="http://schemas.openxmlformats.org/drawingml/2006/main">
+          <a:bodyPr/>
+          <a:p/>
+        </p:txBody>
       </p:sp>
       <p:sp>
         <p:nvSpPr>
@@ -4234,6 +4350,10 @@
           </a:prstGeom>
           <a:noFill xmlns:a="http://schemas.openxmlformats.org/drawingml/2006/main"/>
         </p:spPr>
+        <p:txBody xmlns:a="http://schemas.openxmlformats.org/drawingml/2006/main">
+          <a:bodyPr/>
+          <a:p/>
+        </p:txBody>
       </p:sp>
       <p:sp>
         <p:nvSpPr>
@@ -4379,6 +4499,10 @@
             <a:prstDash val="solid"/>
           </a:ln>
         </p:spPr>
+        <p:txBody xmlns:a="http://schemas.openxmlformats.org/drawingml/2006/main">
+          <a:bodyPr/>
+          <a:p/>
+        </p:txBody>
       </p:sp>
       <p:sp>
         <p:nvSpPr>
@@ -4406,6 +4530,10 @@
           </a:prstGeom>
           <a:noFill xmlns:a="http://schemas.openxmlformats.org/drawingml/2006/main"/>
         </p:spPr>
+        <p:txBody xmlns:a="http://schemas.openxmlformats.org/drawingml/2006/main">
+          <a:bodyPr/>
+          <a:p/>
+        </p:txBody>
       </p:sp>
       <p:sp>
         <p:nvSpPr>
@@ -4478,6 +4606,10 @@
           </a:prstGeom>
           <a:noFill xmlns:a="http://schemas.openxmlformats.org/drawingml/2006/main"/>
         </p:spPr>
+        <p:txBody xmlns:a="http://schemas.openxmlformats.org/drawingml/2006/main">
+          <a:bodyPr/>
+          <a:p/>
+        </p:txBody>
       </p:sp>
       <p:sp>
         <p:nvSpPr>
@@ -4550,6 +4682,10 @@
           </a:prstGeom>
           <a:noFill xmlns:a="http://schemas.openxmlformats.org/drawingml/2006/main"/>
         </p:spPr>
+        <p:txBody xmlns:a="http://schemas.openxmlformats.org/drawingml/2006/main">
+          <a:bodyPr/>
+          <a:p/>
+        </p:txBody>
       </p:sp>
       <p:sp>
         <p:nvSpPr>
@@ -4695,6 +4831,10 @@
             <a:prstDash val="solid"/>
           </a:ln>
         </p:spPr>
+        <p:txBody xmlns:a="http://schemas.openxmlformats.org/drawingml/2006/main">
+          <a:bodyPr/>
+          <a:p/>
+        </p:txBody>
       </p:sp>
       <p:sp>
         <p:nvSpPr>
@@ -4722,6 +4862,10 @@
           </a:prstGeom>
           <a:noFill xmlns:a="http://schemas.openxmlformats.org/drawingml/2006/main"/>
         </p:spPr>
+        <p:txBody xmlns:a="http://schemas.openxmlformats.org/drawingml/2006/main">
+          <a:bodyPr/>
+          <a:p/>
+        </p:txBody>
       </p:sp>
       <p:sp>
         <p:nvSpPr>
@@ -4794,6 +4938,10 @@
           </a:prstGeom>
           <a:noFill xmlns:a="http://schemas.openxmlformats.org/drawingml/2006/main"/>
         </p:spPr>
+        <p:txBody xmlns:a="http://schemas.openxmlformats.org/drawingml/2006/main">
+          <a:bodyPr/>
+          <a:p/>
+        </p:txBody>
       </p:sp>
       <p:sp>
         <p:nvSpPr>
@@ -4866,6 +5014,10 @@
           </a:prstGeom>
           <a:noFill xmlns:a="http://schemas.openxmlformats.org/drawingml/2006/main"/>
         </p:spPr>
+        <p:txBody xmlns:a="http://schemas.openxmlformats.org/drawingml/2006/main">
+          <a:bodyPr/>
+          <a:p/>
+        </p:txBody>
       </p:sp>
       <p:sp>
         <p:nvSpPr>
@@ -4938,6 +5090,10 @@
           </a:prstGeom>
           <a:noFill xmlns:a="http://schemas.openxmlformats.org/drawingml/2006/main"/>
         </p:spPr>
+        <p:txBody xmlns:a="http://schemas.openxmlformats.org/drawingml/2006/main">
+          <a:bodyPr/>
+          <a:p/>
+        </p:txBody>
       </p:sp>
       <p:sp>
         <p:nvSpPr>
@@ -5083,6 +5239,10 @@
             <a:prstDash val="solid"/>
           </a:ln>
         </p:spPr>
+        <p:txBody xmlns:a="http://schemas.openxmlformats.org/drawingml/2006/main">
+          <a:bodyPr/>
+          <a:p/>
+        </p:txBody>
       </p:sp>
       <p:sp>
         <p:nvSpPr>
@@ -5110,6 +5270,10 @@
           </a:prstGeom>
           <a:noFill xmlns:a="http://schemas.openxmlformats.org/drawingml/2006/main"/>
         </p:spPr>
+        <p:txBody xmlns:a="http://schemas.openxmlformats.org/drawingml/2006/main">
+          <a:bodyPr/>
+          <a:p/>
+        </p:txBody>
       </p:sp>
       <p:sp>
         <p:nvSpPr>
@@ -5182,6 +5346,10 @@
           </a:prstGeom>
           <a:noFill xmlns:a="http://schemas.openxmlformats.org/drawingml/2006/main"/>
         </p:spPr>
+        <p:txBody xmlns:a="http://schemas.openxmlformats.org/drawingml/2006/main">
+          <a:bodyPr/>
+          <a:p/>
+        </p:txBody>
       </p:sp>
       <p:sp>
         <p:nvSpPr>
@@ -5254,6 +5422,10 @@
           </a:prstGeom>
           <a:noFill xmlns:a="http://schemas.openxmlformats.org/drawingml/2006/main"/>
         </p:spPr>
+        <p:txBody xmlns:a="http://schemas.openxmlformats.org/drawingml/2006/main">
+          <a:bodyPr/>
+          <a:p/>
+        </p:txBody>
       </p:sp>
       <p:sp>
         <p:nvSpPr>
@@ -5326,6 +5498,10 @@
           </a:prstGeom>
           <a:noFill xmlns:a="http://schemas.openxmlformats.org/drawingml/2006/main"/>
         </p:spPr>
+        <p:txBody xmlns:a="http://schemas.openxmlformats.org/drawingml/2006/main">
+          <a:bodyPr/>
+          <a:p/>
+        </p:txBody>
       </p:sp>
       <p:sp>
         <p:nvSpPr>
@@ -5471,6 +5647,10 @@
             <a:prstDash val="solid"/>
           </a:ln>
         </p:spPr>
+        <p:txBody xmlns:a="http://schemas.openxmlformats.org/drawingml/2006/main">
+          <a:bodyPr/>
+          <a:p/>
+        </p:txBody>
       </p:sp>
       <p:sp>
         <p:nvSpPr>
@@ -5498,6 +5678,10 @@
           </a:prstGeom>
           <a:noFill xmlns:a="http://schemas.openxmlformats.org/drawingml/2006/main"/>
         </p:spPr>
+        <p:txBody xmlns:a="http://schemas.openxmlformats.org/drawingml/2006/main">
+          <a:bodyPr/>
+          <a:p/>
+        </p:txBody>
       </p:sp>
       <p:sp>
         <p:nvSpPr>
@@ -5570,6 +5754,10 @@
           </a:prstGeom>
           <a:noFill xmlns:a="http://schemas.openxmlformats.org/drawingml/2006/main"/>
         </p:spPr>
+        <p:txBody xmlns:a="http://schemas.openxmlformats.org/drawingml/2006/main">
+          <a:bodyPr/>
+          <a:p/>
+        </p:txBody>
       </p:sp>
       <p:sp>
         <p:nvSpPr>
@@ -5642,6 +5830,10 @@
           </a:prstGeom>
           <a:noFill xmlns:a="http://schemas.openxmlformats.org/drawingml/2006/main"/>
         </p:spPr>
+        <p:txBody xmlns:a="http://schemas.openxmlformats.org/drawingml/2006/main">
+          <a:bodyPr/>
+          <a:p/>
+        </p:txBody>
       </p:sp>
       <p:sp>
         <p:nvSpPr>
@@ -5714,6 +5906,10 @@
           </a:prstGeom>
           <a:noFill xmlns:a="http://schemas.openxmlformats.org/drawingml/2006/main"/>
         </p:spPr>
+        <p:txBody xmlns:a="http://schemas.openxmlformats.org/drawingml/2006/main">
+          <a:bodyPr/>
+          <a:p/>
+        </p:txBody>
       </p:sp>
       <p:sp>
         <p:nvSpPr>
@@ -5755,7 +5951,7 @@
                   <a:srgbClr val="243B53"/>
                 </a:solidFill>
               </a:rPr>
-              <a:t>Workbook build and .twbx export remain the final manual Tableau step.</a:t>
+              <a:t>The packaged workbook (nifty50_dashboard.twbx) is ready. Open in Tableau Desktop to publish..</a:t>
             </a:r>
           </a:p>
         </p:txBody>
@@ -5859,6 +6055,10 @@
             <a:prstDash val="solid"/>
           </a:ln>
         </p:spPr>
+        <p:txBody xmlns:a="http://schemas.openxmlformats.org/drawingml/2006/main">
+          <a:bodyPr/>
+          <a:p/>
+        </p:txBody>
       </p:sp>
       <p:sp>
         <p:nvSpPr>
@@ -5886,6 +6086,10 @@
           </a:prstGeom>
           <a:noFill xmlns:a="http://schemas.openxmlformats.org/drawingml/2006/main"/>
         </p:spPr>
+        <p:txBody xmlns:a="http://schemas.openxmlformats.org/drawingml/2006/main">
+          <a:bodyPr/>
+          <a:p/>
+        </p:txBody>
       </p:sp>
       <p:sp>
         <p:nvSpPr>
@@ -5958,6 +6162,10 @@
           </a:prstGeom>
           <a:noFill xmlns:a="http://schemas.openxmlformats.org/drawingml/2006/main"/>
         </p:spPr>
+        <p:txBody xmlns:a="http://schemas.openxmlformats.org/drawingml/2006/main">
+          <a:bodyPr/>
+          <a:p/>
+        </p:txBody>
       </p:sp>
       <p:sp>
         <p:nvSpPr>
@@ -6030,6 +6238,10 @@
           </a:prstGeom>
           <a:noFill xmlns:a="http://schemas.openxmlformats.org/drawingml/2006/main"/>
         </p:spPr>
+        <p:txBody xmlns:a="http://schemas.openxmlformats.org/drawingml/2006/main">
+          <a:bodyPr/>
+          <a:p/>
+        </p:txBody>
       </p:sp>
       <p:sp>
         <p:nvSpPr>
@@ -6102,6 +6314,10 @@
           </a:prstGeom>
           <a:noFill xmlns:a="http://schemas.openxmlformats.org/drawingml/2006/main"/>
         </p:spPr>
+        <p:txBody xmlns:a="http://schemas.openxmlformats.org/drawingml/2006/main">
+          <a:bodyPr/>
+          <a:p/>
+        </p:txBody>
       </p:sp>
       <p:sp>
         <p:nvSpPr>

</xml_diff>